<commit_message>
Redesign Week 3 PowerPoint decks and fix PowerPoint repair-on-open bug
</commit_message>
<xml_diff>
--- a/docs/week3/architecture-v1.pptx
+++ b/docs/week3/architecture-v1.pptx
@@ -1150,8 +1150,8 @@
         </p:nvSpPr>
         <p:spPr>
           <a:xfrm>
-            <a:off x="731520" y="1828800"/>
-            <a:ext cx="10725912" cy="822960"/>
+            <a:off x="640080" y="2194560"/>
+            <a:ext cx="10881360" cy="914400"/>
           </a:xfrm>
           <a:prstGeom prst="rect">
             <a:avLst/>
@@ -1167,17 +1167,17 @@
               <a:buNone/>
             </a:pPr>
             <a:r>
-              <a:rPr lang="en-US" sz="3600" b="1" dirty="0">
+              <a:rPr lang="en-US" sz="3800" b="1" dirty="0">
                 <a:solidFill>
                   <a:srgbClr val="FFFFFF"/>
                 </a:solidFill>
-                <a:latin typeface="Cambria" pitchFamily="34" charset="0"/>
-                <a:ea typeface="Cambria" pitchFamily="34" charset="-122"/>
-                <a:cs typeface="Cambria" pitchFamily="34" charset="-120"/>
+                <a:latin typeface="Arial" pitchFamily="34" charset="0"/>
+                <a:ea typeface="Arial" pitchFamily="34"/>
+                <a:cs typeface="Arial" pitchFamily="34"/>
               </a:rPr>
               <a:t>Product Return Request</a:t>
             </a:r>
-            <a:endParaRPr lang="en-US" sz="3600" dirty="0"/>
+            <a:endParaRPr lang="en-US" sz="3800" dirty="0"/>
           </a:p>
         </p:txBody>
       </p:sp>
@@ -1189,8 +1189,8 @@
         </p:nvSpPr>
         <p:spPr>
           <a:xfrm>
-            <a:off x="731520" y="2606040"/>
-            <a:ext cx="10725912" cy="640080"/>
+            <a:off x="640080" y="3017520"/>
+            <a:ext cx="10881360" cy="548640"/>
           </a:xfrm>
           <a:prstGeom prst="rect">
             <a:avLst/>
@@ -1206,17 +1206,17 @@
               <a:buNone/>
             </a:pPr>
             <a:r>
-              <a:rPr lang="en-US" sz="2200" dirty="0">
+              <a:rPr lang="en-US" sz="1900" dirty="0">
                 <a:solidFill>
-                  <a:srgbClr val="CADCFC"/>
+                  <a:srgbClr val="0E8C86"/>
                 </a:solidFill>
                 <a:latin typeface="Calibri" pitchFamily="34" charset="0"/>
-                <a:ea typeface="Calibri" pitchFamily="34" charset="-122"/>
-                <a:cs typeface="Calibri" pitchFamily="34" charset="-120"/>
+                <a:ea typeface="Calibri" pitchFamily="34"/>
+                <a:cs typeface="Calibri" pitchFamily="34"/>
               </a:rPr>
               <a:t>Three-Tier Architecture &amp; Responsibilities</a:t>
             </a:r>
-            <a:endParaRPr lang="en-US" sz="2200" dirty="0"/>
+            <a:endParaRPr lang="en-US" sz="1900" dirty="0"/>
           </a:p>
         </p:txBody>
       </p:sp>
@@ -1228,8 +1228,8 @@
         </p:nvSpPr>
         <p:spPr>
           <a:xfrm>
-            <a:off x="731520" y="3474720"/>
-            <a:ext cx="10725912" cy="731520"/>
+            <a:off x="640080" y="4114800"/>
+            <a:ext cx="10881360" cy="320040"/>
           </a:xfrm>
           <a:prstGeom prst="rect">
             <a:avLst/>
@@ -1242,43 +1242,59 @@
           <a:lstStyle/>
           <a:p>
             <a:pPr indent="0" marL="0">
-              <a:lnSpc>
-                <a:spcPct val="130000"/>
-              </a:lnSpc>
               <a:buNone/>
             </a:pPr>
             <a:r>
-              <a:rPr lang="en-US" sz="1400" dirty="0">
+              <a:rPr lang="en-US" sz="1300" dirty="0">
                 <a:solidFill>
-                  <a:srgbClr val="CADCFC"/>
+                  <a:srgbClr val="AAB0C8"/>
                 </a:solidFill>
                 <a:latin typeface="Calibri" pitchFamily="34" charset="0"/>
-                <a:ea typeface="Calibri" pitchFamily="34" charset="-122"/>
-                <a:cs typeface="Calibri" pitchFamily="34" charset="-120"/>
+                <a:ea typeface="Calibri" pitchFamily="34"/>
+                <a:cs typeface="Calibri" pitchFamily="34"/>
               </a:rPr>
-              <a:t>MIS 3371 • Transaction Processing Systems I • Week 3</a:t>
+              <a:t>MIS 3371  •  Transaction Processing Systems I  •  Week 3</a:t>
             </a:r>
-            <a:endParaRPr lang="en-US" sz="1400" dirty="0"/>
+            <a:endParaRPr lang="en-US" sz="1300" dirty="0"/>
           </a:p>
+        </p:txBody>
+      </p:sp>
+      <p:sp>
+        <p:nvSpPr>
+          <p:cNvPr id="5" name="Text 3"/>
+          <p:cNvSpPr txBox="1"/>
+          <p:nvPr/>
+        </p:nvSpPr>
+        <p:spPr>
+          <a:xfrm>
+            <a:off x="640080" y="4434840"/>
+            <a:ext cx="10881360" cy="320040"/>
+          </a:xfrm>
+          <a:prstGeom prst="rect">
+            <a:avLst/>
+          </a:prstGeom>
+          <a:noFill/>
+          <a:ln/>
+        </p:spPr>
+        <p:txBody>
+          <a:bodyPr wrap="square" lIns="0" tIns="0" rIns="0" bIns="0" rtlCol="0" anchor="ctr"/>
+          <a:lstStyle/>
           <a:p>
             <a:pPr indent="0" marL="0">
-              <a:lnSpc>
-                <a:spcPct val="130000"/>
-              </a:lnSpc>
               <a:buNone/>
             </a:pPr>
             <a:r>
-              <a:rPr lang="en-US" sz="1400" dirty="0">
+              <a:rPr lang="en-US" sz="1300" dirty="0">
                 <a:solidFill>
-                  <a:srgbClr val="CADCFC"/>
+                  <a:srgbClr val="AAB0C8"/>
                 </a:solidFill>
                 <a:latin typeface="Calibri" pitchFamily="34" charset="0"/>
-                <a:ea typeface="Calibri" pitchFamily="34" charset="-122"/>
-                <a:cs typeface="Calibri" pitchFamily="34" charset="-120"/>
+                <a:ea typeface="Calibri" pitchFamily="34"/>
+                <a:cs typeface="Calibri" pitchFamily="34"/>
               </a:rPr>
               <a:t>Product Return Request Team</a:t>
             </a:r>
-            <a:endParaRPr lang="en-US" sz="1400" dirty="0"/>
+            <a:endParaRPr lang="en-US" sz="1300" dirty="0"/>
           </a:p>
         </p:txBody>
       </p:sp>
@@ -1322,8 +1338,8 @@
         </p:nvSpPr>
         <p:spPr>
           <a:xfrm>
-            <a:off x="548640" y="320040"/>
-            <a:ext cx="11091672" cy="548640"/>
+            <a:off x="457200" y="320040"/>
+            <a:ext cx="11247120" cy="548640"/>
           </a:xfrm>
           <a:prstGeom prst="rect">
             <a:avLst/>
@@ -1339,17 +1355,17 @@
               <a:buNone/>
             </a:pPr>
             <a:r>
-              <a:rPr lang="en-US" sz="2600" b="1" dirty="0">
+              <a:rPr lang="en-US" sz="2800" b="1" dirty="0">
                 <a:solidFill>
                   <a:srgbClr val="1E2761"/>
                 </a:solidFill>
-                <a:latin typeface="Cambria" pitchFamily="34" charset="0"/>
-                <a:ea typeface="Cambria" pitchFamily="34" charset="-122"/>
-                <a:cs typeface="Cambria" pitchFamily="34" charset="-120"/>
+                <a:latin typeface="Arial" pitchFamily="34" charset="0"/>
+                <a:ea typeface="Arial" pitchFamily="34"/>
+                <a:cs typeface="Arial" pitchFamily="34"/>
               </a:rPr>
               <a:t>Three-Tier Architecture</a:t>
             </a:r>
-            <a:endParaRPr lang="en-US" sz="2600" dirty="0"/>
+            <a:endParaRPr lang="en-US" sz="2800" dirty="0"/>
           </a:p>
         </p:txBody>
       </p:sp>
@@ -1362,15 +1378,15 @@
         <p:spPr>
           <a:xfrm>
             <a:off x="548640" y="1554480"/>
-            <a:ext cx="11091672" cy="1005840"/>
+            <a:ext cx="11064240" cy="1051560"/>
           </a:xfrm>
           <a:prstGeom prst="roundRect">
             <a:avLst>
-              <a:gd name="adj" fmla="val 7273"/>
+              <a:gd name="adj" fmla="val 4783"/>
             </a:avLst>
           </a:prstGeom>
           <a:solidFill>
-            <a:srgbClr val="CADCFC"/>
+            <a:srgbClr val="FFFFFF"/>
           </a:solidFill>
           <a:ln w="12700">
             <a:solidFill>
@@ -1378,13 +1394,6 @@
             </a:solidFill>
             <a:prstDash val="solid"/>
           </a:ln>
-          <a:effectLst>
-            <a:outerShdw sx="100000" sy="100000" kx="0" ky="0" algn="bl" rotWithShape="0" blurRad="38100" dist="25400" dir="5400000">
-              <a:srgbClr val="000000">
-                <a:alpha val="15000"/>
-              </a:srgbClr>
-            </a:outerShdw>
-          </a:effectLst>
         </p:spPr>
       </p:sp>
       <p:sp>
@@ -1395,8 +1404,8 @@
         </p:nvSpPr>
         <p:spPr>
           <a:xfrm>
-            <a:off x="822960" y="1645920"/>
-            <a:ext cx="2743200" cy="822960"/>
+            <a:off x="822960" y="1554480"/>
+            <a:ext cx="2926080" cy="1051560"/>
           </a:xfrm>
           <a:prstGeom prst="rect">
             <a:avLst/>
@@ -1412,17 +1421,17 @@
               <a:buNone/>
             </a:pPr>
             <a:r>
-              <a:rPr lang="en-US" sz="1600" b="1" dirty="0">
+              <a:rPr lang="en-US" sz="1700" b="1" dirty="0">
                 <a:solidFill>
                   <a:srgbClr val="1E2761"/>
                 </a:solidFill>
-                <a:latin typeface="Cambria" pitchFamily="34" charset="0"/>
-                <a:ea typeface="Cambria" pitchFamily="34" charset="-122"/>
-                <a:cs typeface="Cambria" pitchFamily="34" charset="-120"/>
+                <a:latin typeface="Arial" pitchFamily="34" charset="0"/>
+                <a:ea typeface="Arial" pitchFamily="34"/>
+                <a:cs typeface="Arial" pitchFamily="34"/>
               </a:rPr>
               <a:t>Presentation Tier</a:t>
             </a:r>
-            <a:endParaRPr lang="en-US" sz="1600" dirty="0"/>
+            <a:endParaRPr lang="en-US" sz="1700" dirty="0"/>
           </a:p>
         </p:txBody>
       </p:sp>
@@ -1434,8 +1443,8 @@
         </p:nvSpPr>
         <p:spPr>
           <a:xfrm>
-            <a:off x="3657600" y="1645920"/>
-            <a:ext cx="7708392" cy="822960"/>
+            <a:off x="3840480" y="1554480"/>
+            <a:ext cx="7498080" cy="1051560"/>
           </a:xfrm>
           <a:prstGeom prst="rect">
             <a:avLst/>
@@ -1448,19 +1457,16 @@
           <a:lstStyle/>
           <a:p>
             <a:pPr indent="0" marL="0">
-              <a:lnSpc>
-                <a:spcPct val="130000"/>
-              </a:lnSpc>
               <a:buNone/>
             </a:pPr>
             <a:r>
               <a:rPr lang="en-US" sz="1250" dirty="0">
                 <a:solidFill>
-                  <a:srgbClr val="202020"/>
+                  <a:srgbClr val="222533"/>
                 </a:solidFill>
                 <a:latin typeface="Calibri" pitchFamily="34" charset="0"/>
-                <a:ea typeface="Calibri" pitchFamily="34" charset="-122"/>
-                <a:cs typeface="Calibri" pitchFamily="34" charset="-120"/>
+                <a:ea typeface="Calibri" pitchFamily="34"/>
+                <a:cs typeface="Calibri" pitchFamily="34"/>
               </a:rPr>
               <a:t>Return Request Form • Status Tracker • Supervisor Queue</a:t>
             </a:r>
@@ -1476,16 +1482,16 @@
         </p:nvSpPr>
         <p:spPr>
           <a:xfrm>
-            <a:off x="548640" y="3200400"/>
-            <a:ext cx="11091672" cy="1005840"/>
+            <a:off x="548640" y="3063240"/>
+            <a:ext cx="11064240" cy="1051560"/>
           </a:xfrm>
           <a:prstGeom prst="roundRect">
             <a:avLst>
-              <a:gd name="adj" fmla="val 7273"/>
+              <a:gd name="adj" fmla="val 4783"/>
             </a:avLst>
           </a:prstGeom>
           <a:solidFill>
-            <a:srgbClr val="D8DEEF"/>
+            <a:srgbClr val="F7F8FA"/>
           </a:solidFill>
           <a:ln w="12700">
             <a:solidFill>
@@ -1493,13 +1499,6 @@
             </a:solidFill>
             <a:prstDash val="solid"/>
           </a:ln>
-          <a:effectLst>
-            <a:outerShdw sx="100000" sy="100000" kx="0" ky="0" algn="bl" rotWithShape="0" blurRad="38100" dist="25400" dir="5400000">
-              <a:srgbClr val="000000">
-                <a:alpha val="15000"/>
-              </a:srgbClr>
-            </a:outerShdw>
-          </a:effectLst>
         </p:spPr>
       </p:sp>
       <p:sp>
@@ -1510,8 +1509,8 @@
         </p:nvSpPr>
         <p:spPr>
           <a:xfrm>
-            <a:off x="822960" y="3291840"/>
-            <a:ext cx="2743200" cy="822960"/>
+            <a:off x="822960" y="3063240"/>
+            <a:ext cx="2926080" cy="1051560"/>
           </a:xfrm>
           <a:prstGeom prst="rect">
             <a:avLst/>
@@ -1527,17 +1526,17 @@
               <a:buNone/>
             </a:pPr>
             <a:r>
-              <a:rPr lang="en-US" sz="1600" b="1" dirty="0">
+              <a:rPr lang="en-US" sz="1700" b="1" dirty="0">
                 <a:solidFill>
-                  <a:srgbClr val="3A4B7A"/>
+                  <a:srgbClr val="1E2761"/>
                 </a:solidFill>
-                <a:latin typeface="Cambria" pitchFamily="34" charset="0"/>
-                <a:ea typeface="Cambria" pitchFamily="34" charset="-122"/>
-                <a:cs typeface="Cambria" pitchFamily="34" charset="-120"/>
+                <a:latin typeface="Arial" pitchFamily="34" charset="0"/>
+                <a:ea typeface="Arial" pitchFamily="34"/>
+                <a:cs typeface="Arial" pitchFamily="34"/>
               </a:rPr>
               <a:t>Application Tier</a:t>
             </a:r>
-            <a:endParaRPr lang="en-US" sz="1600" dirty="0"/>
+            <a:endParaRPr lang="en-US" sz="1700" dirty="0"/>
           </a:p>
         </p:txBody>
       </p:sp>
@@ -1549,8 +1548,8 @@
         </p:nvSpPr>
         <p:spPr>
           <a:xfrm>
-            <a:off x="3657600" y="3291840"/>
-            <a:ext cx="7708392" cy="822960"/>
+            <a:off x="3840480" y="3063240"/>
+            <a:ext cx="7498080" cy="1051560"/>
           </a:xfrm>
           <a:prstGeom prst="rect">
             <a:avLst/>
@@ -1563,19 +1562,16 @@
           <a:lstStyle/>
           <a:p>
             <a:pPr indent="0" marL="0">
-              <a:lnSpc>
-                <a:spcPct val="130000"/>
-              </a:lnSpc>
               <a:buNone/>
             </a:pPr>
             <a:r>
               <a:rPr lang="en-US" sz="1250" dirty="0">
                 <a:solidFill>
-                  <a:srgbClr val="202020"/>
+                  <a:srgbClr val="222533"/>
                 </a:solidFill>
                 <a:latin typeface="Calibri" pitchFamily="34" charset="0"/>
-                <a:ea typeface="Calibri" pitchFamily="34" charset="-122"/>
-                <a:cs typeface="Calibri" pitchFamily="34" charset="-120"/>
+                <a:ea typeface="Calibri" pitchFamily="34"/>
+                <a:cs typeface="Calibri" pitchFamily="34"/>
               </a:rPr>
               <a:t>Validation &amp; Business Rules Engine • Workflow / State Transition Logic</a:t>
             </a:r>
@@ -1591,16 +1587,16 @@
         </p:nvSpPr>
         <p:spPr>
           <a:xfrm>
-            <a:off x="548640" y="4846320"/>
-            <a:ext cx="11091672" cy="1005840"/>
+            <a:off x="548640" y="4572000"/>
+            <a:ext cx="11064240" cy="1051560"/>
           </a:xfrm>
           <a:prstGeom prst="roundRect">
             <a:avLst>
-              <a:gd name="adj" fmla="val 7273"/>
+              <a:gd name="adj" fmla="val 4783"/>
             </a:avLst>
           </a:prstGeom>
           <a:solidFill>
-            <a:srgbClr val="E4F2EB"/>
+            <a:srgbClr val="E7E9F3"/>
           </a:solidFill>
           <a:ln w="12700">
             <a:solidFill>
@@ -1608,13 +1604,6 @@
             </a:solidFill>
             <a:prstDash val="solid"/>
           </a:ln>
-          <a:effectLst>
-            <a:outerShdw sx="100000" sy="100000" kx="0" ky="0" algn="bl" rotWithShape="0" blurRad="38100" dist="25400" dir="5400000">
-              <a:srgbClr val="000000">
-                <a:alpha val="15000"/>
-              </a:srgbClr>
-            </a:outerShdw>
-          </a:effectLst>
         </p:spPr>
       </p:sp>
       <p:sp>
@@ -1625,8 +1614,8 @@
         </p:nvSpPr>
         <p:spPr>
           <a:xfrm>
-            <a:off x="822960" y="4937760"/>
-            <a:ext cx="2743200" cy="822960"/>
+            <a:off x="822960" y="4572000"/>
+            <a:ext cx="2926080" cy="1051560"/>
           </a:xfrm>
           <a:prstGeom prst="rect">
             <a:avLst/>
@@ -1642,17 +1631,17 @@
               <a:buNone/>
             </a:pPr>
             <a:r>
-              <a:rPr lang="en-US" sz="1600" b="1" dirty="0">
+              <a:rPr lang="en-US" sz="1700" b="1" dirty="0">
                 <a:solidFill>
-                  <a:srgbClr val="1E6B4E"/>
+                  <a:srgbClr val="1E2761"/>
                 </a:solidFill>
-                <a:latin typeface="Cambria" pitchFamily="34" charset="0"/>
-                <a:ea typeface="Cambria" pitchFamily="34" charset="-122"/>
-                <a:cs typeface="Cambria" pitchFamily="34" charset="-120"/>
+                <a:latin typeface="Arial" pitchFamily="34" charset="0"/>
+                <a:ea typeface="Arial" pitchFamily="34"/>
+                <a:cs typeface="Arial" pitchFamily="34"/>
               </a:rPr>
               <a:t>Data Tier</a:t>
             </a:r>
-            <a:endParaRPr lang="en-US" sz="1600" dirty="0"/>
+            <a:endParaRPr lang="en-US" sz="1700" dirty="0"/>
           </a:p>
         </p:txBody>
       </p:sp>
@@ -1664,8 +1653,8 @@
         </p:nvSpPr>
         <p:spPr>
           <a:xfrm>
-            <a:off x="3657600" y="4937760"/>
-            <a:ext cx="7708392" cy="822960"/>
+            <a:off x="3840480" y="4572000"/>
+            <a:ext cx="7498080" cy="1051560"/>
           </a:xfrm>
           <a:prstGeom prst="rect">
             <a:avLst/>
@@ -1678,19 +1667,16 @@
           <a:lstStyle/>
           <a:p>
             <a:pPr indent="0" marL="0">
-              <a:lnSpc>
-                <a:spcPct val="130000"/>
-              </a:lnSpc>
               <a:buNone/>
             </a:pPr>
             <a:r>
               <a:rPr lang="en-US" sz="1250" dirty="0">
                 <a:solidFill>
-                  <a:srgbClr val="202020"/>
+                  <a:srgbClr val="222533"/>
                 </a:solidFill>
                 <a:latin typeface="Calibri" pitchFamily="34" charset="0"/>
-                <a:ea typeface="Calibri" pitchFamily="34" charset="-122"/>
-                <a:cs typeface="Calibri" pitchFamily="34" charset="-120"/>
+                <a:ea typeface="Calibri" pitchFamily="34"/>
+                <a:cs typeface="Calibri" pitchFamily="34"/>
               </a:rPr>
               <a:t>Return Requests DB • Audit / History Log</a:t>
             </a:r>
@@ -1706,16 +1692,16 @@
         </p:nvSpPr>
         <p:spPr>
           <a:xfrm>
-            <a:off x="2377440" y="2560320"/>
-            <a:ext cx="0" cy="640080"/>
+            <a:off x="1645920" y="2606040"/>
+            <a:ext cx="9144" cy="457200"/>
           </a:xfrm>
           <a:prstGeom prst="line">
             <a:avLst/>
           </a:prstGeom>
           <a:noFill/>
-          <a:ln w="22225">
+          <a:ln w="12700">
             <a:solidFill>
-              <a:srgbClr val="3A4B7A"/>
+              <a:srgbClr val="1E2761"/>
             </a:solidFill>
             <a:prstDash val="solid"/>
             <a:tailEnd type="triangle"/>
@@ -1730,8 +1716,8 @@
         </p:nvSpPr>
         <p:spPr>
           <a:xfrm>
-            <a:off x="2514600" y="2743200"/>
-            <a:ext cx="1737360" cy="274320"/>
+            <a:off x="1737360" y="2624328"/>
+            <a:ext cx="1463040" cy="274320"/>
           </a:xfrm>
           <a:prstGeom prst="rect">
             <a:avLst/>
@@ -1743,21 +1729,21 @@
           <a:bodyPr wrap="square" lIns="0" tIns="0" rIns="0" bIns="0" rtlCol="0" anchor="ctr"/>
           <a:lstStyle/>
           <a:p>
-            <a:pPr algn="l" indent="0" marL="0">
+            <a:pPr indent="0" marL="0">
               <a:buNone/>
             </a:pPr>
             <a:r>
-              <a:rPr lang="en-US" sz="1000" dirty="0">
+              <a:rPr lang="en-US" sz="1050" b="1" dirty="0">
                 <a:solidFill>
-                  <a:srgbClr val="3A4B7A"/>
+                  <a:srgbClr val="1E2761"/>
                 </a:solidFill>
                 <a:latin typeface="Calibri" pitchFamily="34" charset="0"/>
-                <a:ea typeface="Calibri" pitchFamily="34" charset="-122"/>
-                <a:cs typeface="Calibri" pitchFamily="34" charset="-120"/>
+                <a:ea typeface="Calibri" pitchFamily="34"/>
+                <a:cs typeface="Calibri" pitchFamily="34"/>
               </a:rPr>
               <a:t>request / input</a:t>
             </a:r>
-            <a:endParaRPr lang="en-US" sz="1000" dirty="0"/>
+            <a:endParaRPr lang="en-US" sz="1050" dirty="0"/>
           </a:p>
         </p:txBody>
       </p:sp>
@@ -1768,15 +1754,15 @@
           <p:nvPr/>
         </p:nvSpPr>
         <p:spPr>
-          <a:xfrm>
-            <a:off x="5120640" y="3200400"/>
-            <a:ext cx="0" cy="-640080"/>
+          <a:xfrm flipV="1">
+            <a:off x="3291840" y="2606040"/>
+            <a:ext cx="9144" cy="457200"/>
           </a:xfrm>
           <a:prstGeom prst="line">
             <a:avLst/>
           </a:prstGeom>
           <a:noFill/>
-          <a:ln w="22225">
+          <a:ln w="12700">
             <a:solidFill>
               <a:srgbClr val="1E2761"/>
             </a:solidFill>
@@ -1793,7 +1779,7 @@
         </p:nvSpPr>
         <p:spPr>
           <a:xfrm>
-            <a:off x="5257800" y="2743200"/>
+            <a:off x="3383280" y="2770632"/>
             <a:ext cx="1737360" cy="274320"/>
           </a:xfrm>
           <a:prstGeom prst="rect">
@@ -1806,21 +1792,21 @@
           <a:bodyPr wrap="square" lIns="0" tIns="0" rIns="0" bIns="0" rtlCol="0" anchor="ctr"/>
           <a:lstStyle/>
           <a:p>
-            <a:pPr algn="l" indent="0" marL="0">
+            <a:pPr indent="0" marL="0">
               <a:buNone/>
             </a:pPr>
             <a:r>
-              <a:rPr lang="en-US" sz="1000" dirty="0">
+              <a:rPr lang="en-US" sz="1050" b="1" dirty="0">
                 <a:solidFill>
                   <a:srgbClr val="1E2761"/>
                 </a:solidFill>
                 <a:latin typeface="Calibri" pitchFamily="34" charset="0"/>
-                <a:ea typeface="Calibri" pitchFamily="34" charset="-122"/>
-                <a:cs typeface="Calibri" pitchFamily="34" charset="-120"/>
+                <a:ea typeface="Calibri" pitchFamily="34"/>
+                <a:cs typeface="Calibri" pitchFamily="34"/>
               </a:rPr>
               <a:t>status / response</a:t>
             </a:r>
-            <a:endParaRPr lang="en-US" sz="1000" dirty="0"/>
+            <a:endParaRPr lang="en-US" sz="1050" dirty="0"/>
           </a:p>
         </p:txBody>
       </p:sp>
@@ -1832,16 +1818,16 @@
         </p:nvSpPr>
         <p:spPr>
           <a:xfrm>
-            <a:off x="2377440" y="4206240"/>
-            <a:ext cx="0" cy="640080"/>
+            <a:off x="1645920" y="4114800"/>
+            <a:ext cx="9144" cy="457200"/>
           </a:xfrm>
           <a:prstGeom prst="line">
             <a:avLst/>
           </a:prstGeom>
           <a:noFill/>
-          <a:ln w="22225">
+          <a:ln w="12700">
             <a:solidFill>
-              <a:srgbClr val="1E6B4E"/>
+              <a:srgbClr val="0E8C86"/>
             </a:solidFill>
             <a:prstDash val="solid"/>
             <a:tailEnd type="triangle"/>
@@ -1856,8 +1842,8 @@
         </p:nvSpPr>
         <p:spPr>
           <a:xfrm>
-            <a:off x="2514600" y="4389120"/>
-            <a:ext cx="1737360" cy="274320"/>
+            <a:off x="1737360" y="4133088"/>
+            <a:ext cx="1463040" cy="274320"/>
           </a:xfrm>
           <a:prstGeom prst="rect">
             <a:avLst/>
@@ -1869,21 +1855,21 @@
           <a:bodyPr wrap="square" lIns="0" tIns="0" rIns="0" bIns="0" rtlCol="0" anchor="ctr"/>
           <a:lstStyle/>
           <a:p>
-            <a:pPr algn="l" indent="0" marL="0">
+            <a:pPr indent="0" marL="0">
               <a:buNone/>
             </a:pPr>
             <a:r>
-              <a:rPr lang="en-US" sz="1000" dirty="0">
+              <a:rPr lang="en-US" sz="1050" b="1" dirty="0">
                 <a:solidFill>
-                  <a:srgbClr val="1E6B4E"/>
+                  <a:srgbClr val="0E8C86"/>
                 </a:solidFill>
                 <a:latin typeface="Calibri" pitchFamily="34" charset="0"/>
-                <a:ea typeface="Calibri" pitchFamily="34" charset="-122"/>
-                <a:cs typeface="Calibri" pitchFamily="34" charset="-120"/>
+                <a:ea typeface="Calibri" pitchFamily="34"/>
+                <a:cs typeface="Calibri" pitchFamily="34"/>
               </a:rPr>
               <a:t>persist / read</a:t>
             </a:r>
-            <a:endParaRPr lang="en-US" sz="1000" dirty="0"/>
+            <a:endParaRPr lang="en-US" sz="1050" dirty="0"/>
           </a:p>
         </p:txBody>
       </p:sp>
@@ -1894,17 +1880,17 @@
           <p:nvPr/>
         </p:nvSpPr>
         <p:spPr>
-          <a:xfrm>
-            <a:off x="5120640" y="4846320"/>
-            <a:ext cx="0" cy="-640080"/>
+          <a:xfrm flipV="1">
+            <a:off x="3291840" y="4114800"/>
+            <a:ext cx="9144" cy="457200"/>
           </a:xfrm>
           <a:prstGeom prst="line">
             <a:avLst/>
           </a:prstGeom>
           <a:noFill/>
-          <a:ln w="22225">
+          <a:ln w="12700">
             <a:solidFill>
-              <a:srgbClr val="1E6B4E"/>
+              <a:srgbClr val="0E8C86"/>
             </a:solidFill>
             <a:prstDash val="solid"/>
             <a:tailEnd type="triangle"/>
@@ -1919,8 +1905,8 @@
         </p:nvSpPr>
         <p:spPr>
           <a:xfrm>
-            <a:off x="5257800" y="4389120"/>
-            <a:ext cx="1737360" cy="274320"/>
+            <a:off x="3383280" y="4279392"/>
+            <a:ext cx="1463040" cy="274320"/>
           </a:xfrm>
           <a:prstGeom prst="rect">
             <a:avLst/>
@@ -1932,21 +1918,21 @@
           <a:bodyPr wrap="square" lIns="0" tIns="0" rIns="0" bIns="0" rtlCol="0" anchor="ctr"/>
           <a:lstStyle/>
           <a:p>
-            <a:pPr algn="l" indent="0" marL="0">
+            <a:pPr indent="0" marL="0">
               <a:buNone/>
             </a:pPr>
             <a:r>
-              <a:rPr lang="en-US" sz="1000" dirty="0">
+              <a:rPr lang="en-US" sz="1050" b="1" dirty="0">
                 <a:solidFill>
-                  <a:srgbClr val="1E6B4E"/>
+                  <a:srgbClr val="0E8C86"/>
                 </a:solidFill>
                 <a:latin typeface="Calibri" pitchFamily="34" charset="0"/>
-                <a:ea typeface="Calibri" pitchFamily="34" charset="-122"/>
-                <a:cs typeface="Calibri" pitchFamily="34" charset="-120"/>
+                <a:ea typeface="Calibri" pitchFamily="34"/>
+                <a:cs typeface="Calibri" pitchFamily="34"/>
               </a:rPr>
               <a:t>history / audit</a:t>
             </a:r>
-            <a:endParaRPr lang="en-US" sz="1000" dirty="0"/>
+            <a:endParaRPr lang="en-US" sz="1050" dirty="0"/>
           </a:p>
         </p:txBody>
       </p:sp>
@@ -1990,8 +1976,8 @@
         </p:nvSpPr>
         <p:spPr>
           <a:xfrm>
-            <a:off x="548640" y="320040"/>
-            <a:ext cx="11091672" cy="548640"/>
+            <a:off x="457200" y="320040"/>
+            <a:ext cx="11247120" cy="548640"/>
           </a:xfrm>
           <a:prstGeom prst="rect">
             <a:avLst/>
@@ -2007,17 +1993,17 @@
               <a:buNone/>
             </a:pPr>
             <a:r>
-              <a:rPr lang="en-US" sz="2600" b="1" dirty="0">
+              <a:rPr lang="en-US" sz="2800" b="1" dirty="0">
                 <a:solidFill>
                   <a:srgbClr val="1E2761"/>
                 </a:solidFill>
-                <a:latin typeface="Cambria" pitchFamily="34" charset="0"/>
-                <a:ea typeface="Cambria" pitchFamily="34" charset="-122"/>
-                <a:cs typeface="Cambria" pitchFamily="34" charset="-120"/>
+                <a:latin typeface="Arial" pitchFamily="34" charset="0"/>
+                <a:ea typeface="Arial" pitchFamily="34"/>
+                <a:cs typeface="Arial" pitchFamily="34"/>
               </a:rPr>
               <a:t>Responsibility Matrix</a:t>
             </a:r>
-            <a:endParaRPr lang="en-US" sz="2600" dirty="0"/>
+            <a:endParaRPr lang="en-US" sz="2800" dirty="0"/>
           </a:p>
         </p:txBody>
       </p:sp>
@@ -2029,8 +2015,8 @@
         </p:nvSpPr>
         <p:spPr>
           <a:xfrm>
-            <a:off x="548640" y="868680"/>
-            <a:ext cx="11091672" cy="320040"/>
+            <a:off x="457200" y="868680"/>
+            <a:ext cx="11247120" cy="320040"/>
           </a:xfrm>
           <a:prstGeom prst="rect">
             <a:avLst/>
@@ -2048,11 +2034,11 @@
             <a:r>
               <a:rPr lang="en-US" sz="1300" dirty="0">
                 <a:solidFill>
-                  <a:srgbClr val="555555"/>
+                  <a:srgbClr val="5B6072"/>
                 </a:solidFill>
                 <a:latin typeface="Calibri" pitchFamily="34" charset="0"/>
-                <a:ea typeface="Calibri" pitchFamily="34" charset="-122"/>
-                <a:cs typeface="Calibri" pitchFamily="34" charset="-120"/>
+                <a:ea typeface="Calibri" pitchFamily="34"/>
+                <a:cs typeface="Calibri" pitchFamily="34"/>
               </a:rPr>
               <a:t>Columns: Responsibility | Presentation | Application Logic | Data</a:t>
             </a:r>
@@ -2075,20 +2061,20 @@
           </p:nvPr>
         </p:nvGraphicFramePr>
         <p:xfrm>
-          <a:off x="457200" y="1417320"/>
-          <a:ext cx="11274552" cy="914400"/>
+          <a:off x="457200" y="1645920"/>
+          <a:ext cx="11247120" cy="914400"/>
         </p:xfrm>
         <a:graphic>
           <a:graphicData uri="http://schemas.openxmlformats.org/drawingml/2006/table">
             <a:tbl>
               <a:tblPr/>
               <a:tblGrid>
-                <a:gridCol w="3017520"/>
                 <a:gridCol w="2743200"/>
-                <a:gridCol w="3200400"/>
-                <a:gridCol w="3227832"/>
+                <a:gridCol w="2834640"/>
+                <a:gridCol w="2834640"/>
+                <a:gridCol w="2834640"/>
               </a:tblGrid>
-              <a:tr h="457200">
+              <a:tr h="0">
                 <a:tc>
                   <a:txBody>
                     <a:bodyPr/>
@@ -2103,8 +2089,8 @@
                             <a:srgbClr val="FFFFFF"/>
                           </a:solidFill>
                           <a:latin typeface="Calibri" pitchFamily="34" charset="0"/>
-                          <a:ea typeface="Calibri" pitchFamily="34" charset="-122"/>
-                          <a:cs typeface="Calibri" pitchFamily="34" charset="-120"/>
+                          <a:ea typeface="Calibri" pitchFamily="34"/>
+                          <a:cs typeface="Calibri" pitchFamily="34"/>
                         </a:rPr>
                         <a:t>Responsibility</a:t>
                       </a:r>
@@ -2118,7 +2104,7 @@
                   <a:tcPr marL="91440" marR="91440" marT="45720" marB="45720" anchor="ctr">
                     <a:lnL w="9525" cap="flat" cmpd="sng" algn="ctr">
                       <a:solidFill>
-                        <a:srgbClr val="D9D9D9"/>
+                        <a:srgbClr val="D5D9E0"/>
                       </a:solidFill>
                       <a:prstDash val="solid"/>
                       <a:round/>
@@ -2127,7 +2113,7 @@
                     </a:lnL>
                     <a:lnR w="9525" cap="flat" cmpd="sng" algn="ctr">
                       <a:solidFill>
-                        <a:srgbClr val="D9D9D9"/>
+                        <a:srgbClr val="D5D9E0"/>
                       </a:solidFill>
                       <a:prstDash val="solid"/>
                       <a:round/>
@@ -2136,7 +2122,7 @@
                     </a:lnR>
                     <a:lnT w="9525" cap="flat" cmpd="sng" algn="ctr">
                       <a:solidFill>
-                        <a:srgbClr val="D9D9D9"/>
+                        <a:srgbClr val="D5D9E0"/>
                       </a:solidFill>
                       <a:prstDash val="solid"/>
                       <a:round/>
@@ -2145,7 +2131,7 @@
                     </a:lnT>
                     <a:lnB w="9525" cap="flat" cmpd="sng" algn="ctr">
                       <a:solidFill>
-                        <a:srgbClr val="D9D9D9"/>
+                        <a:srgbClr val="D5D9E0"/>
                       </a:solidFill>
                       <a:prstDash val="solid"/>
                       <a:round/>
@@ -2171,8 +2157,8 @@
                             <a:srgbClr val="FFFFFF"/>
                           </a:solidFill>
                           <a:latin typeface="Calibri" pitchFamily="34" charset="0"/>
-                          <a:ea typeface="Calibri" pitchFamily="34" charset="-122"/>
-                          <a:cs typeface="Calibri" pitchFamily="34" charset="-120"/>
+                          <a:ea typeface="Calibri" pitchFamily="34"/>
+                          <a:cs typeface="Calibri" pitchFamily="34"/>
                         </a:rPr>
                         <a:t>Presentation</a:t>
                       </a:r>
@@ -2186,7 +2172,7 @@
                   <a:tcPr marL="91440" marR="91440" marT="45720" marB="45720" anchor="ctr">
                     <a:lnL w="9525" cap="flat" cmpd="sng" algn="ctr">
                       <a:solidFill>
-                        <a:srgbClr val="D9D9D9"/>
+                        <a:srgbClr val="D5D9E0"/>
                       </a:solidFill>
                       <a:prstDash val="solid"/>
                       <a:round/>
@@ -2195,7 +2181,7 @@
                     </a:lnL>
                     <a:lnR w="9525" cap="flat" cmpd="sng" algn="ctr">
                       <a:solidFill>
-                        <a:srgbClr val="D9D9D9"/>
+                        <a:srgbClr val="D5D9E0"/>
                       </a:solidFill>
                       <a:prstDash val="solid"/>
                       <a:round/>
@@ -2204,7 +2190,7 @@
                     </a:lnR>
                     <a:lnT w="9525" cap="flat" cmpd="sng" algn="ctr">
                       <a:solidFill>
-                        <a:srgbClr val="D9D9D9"/>
+                        <a:srgbClr val="D5D9E0"/>
                       </a:solidFill>
                       <a:prstDash val="solid"/>
                       <a:round/>
@@ -2213,7 +2199,7 @@
                     </a:lnT>
                     <a:lnB w="9525" cap="flat" cmpd="sng" algn="ctr">
                       <a:solidFill>
-                        <a:srgbClr val="D9D9D9"/>
+                        <a:srgbClr val="D5D9E0"/>
                       </a:solidFill>
                       <a:prstDash val="solid"/>
                       <a:round/>
@@ -2239,8 +2225,8 @@
                             <a:srgbClr val="FFFFFF"/>
                           </a:solidFill>
                           <a:latin typeface="Calibri" pitchFamily="34" charset="0"/>
-                          <a:ea typeface="Calibri" pitchFamily="34" charset="-122"/>
-                          <a:cs typeface="Calibri" pitchFamily="34" charset="-120"/>
+                          <a:ea typeface="Calibri" pitchFamily="34"/>
+                          <a:cs typeface="Calibri" pitchFamily="34"/>
                         </a:rPr>
                         <a:t>Application Logic</a:t>
                       </a:r>
@@ -2254,7 +2240,7 @@
                   <a:tcPr marL="91440" marR="91440" marT="45720" marB="45720" anchor="ctr">
                     <a:lnL w="9525" cap="flat" cmpd="sng" algn="ctr">
                       <a:solidFill>
-                        <a:srgbClr val="D9D9D9"/>
+                        <a:srgbClr val="D5D9E0"/>
                       </a:solidFill>
                       <a:prstDash val="solid"/>
                       <a:round/>
@@ -2263,7 +2249,7 @@
                     </a:lnL>
                     <a:lnR w="9525" cap="flat" cmpd="sng" algn="ctr">
                       <a:solidFill>
-                        <a:srgbClr val="D9D9D9"/>
+                        <a:srgbClr val="D5D9E0"/>
                       </a:solidFill>
                       <a:prstDash val="solid"/>
                       <a:round/>
@@ -2272,7 +2258,7 @@
                     </a:lnR>
                     <a:lnT w="9525" cap="flat" cmpd="sng" algn="ctr">
                       <a:solidFill>
-                        <a:srgbClr val="D9D9D9"/>
+                        <a:srgbClr val="D5D9E0"/>
                       </a:solidFill>
                       <a:prstDash val="solid"/>
                       <a:round/>
@@ -2281,7 +2267,7 @@
                     </a:lnT>
                     <a:lnB w="9525" cap="flat" cmpd="sng" algn="ctr">
                       <a:solidFill>
-                        <a:srgbClr val="D9D9D9"/>
+                        <a:srgbClr val="D5D9E0"/>
                       </a:solidFill>
                       <a:prstDash val="solid"/>
                       <a:round/>
@@ -2307,8 +2293,8 @@
                             <a:srgbClr val="FFFFFF"/>
                           </a:solidFill>
                           <a:latin typeface="Calibri" pitchFamily="34" charset="0"/>
-                          <a:ea typeface="Calibri" pitchFamily="34" charset="-122"/>
-                          <a:cs typeface="Calibri" pitchFamily="34" charset="-120"/>
+                          <a:ea typeface="Calibri" pitchFamily="34"/>
+                          <a:cs typeface="Calibri" pitchFamily="34"/>
                         </a:rPr>
                         <a:t>Data</a:t>
                       </a:r>
@@ -2322,7 +2308,7 @@
                   <a:tcPr marL="91440" marR="91440" marT="45720" marB="45720" anchor="ctr">
                     <a:lnL w="9525" cap="flat" cmpd="sng" algn="ctr">
                       <a:solidFill>
-                        <a:srgbClr val="D9D9D9"/>
+                        <a:srgbClr val="D5D9E0"/>
                       </a:solidFill>
                       <a:prstDash val="solid"/>
                       <a:round/>
@@ -2331,7 +2317,7 @@
                     </a:lnL>
                     <a:lnR w="9525" cap="flat" cmpd="sng" algn="ctr">
                       <a:solidFill>
-                        <a:srgbClr val="D9D9D9"/>
+                        <a:srgbClr val="D5D9E0"/>
                       </a:solidFill>
                       <a:prstDash val="solid"/>
                       <a:round/>
@@ -2340,7 +2326,7 @@
                     </a:lnR>
                     <a:lnT w="9525" cap="flat" cmpd="sng" algn="ctr">
                       <a:solidFill>
-                        <a:srgbClr val="D9D9D9"/>
+                        <a:srgbClr val="D5D9E0"/>
                       </a:solidFill>
                       <a:prstDash val="solid"/>
                       <a:round/>
@@ -2349,7 +2335,7 @@
                     </a:lnT>
                     <a:lnB w="9525" cap="flat" cmpd="sng" algn="ctr">
                       <a:solidFill>
-                        <a:srgbClr val="D9D9D9"/>
+                        <a:srgbClr val="D5D9E0"/>
                       </a:solidFill>
                       <a:prstDash val="solid"/>
                       <a:round/>
@@ -2362,7 +2348,7 @@
                   </a:tcPr>
                 </a:tc>
               </a:tr>
-              <a:tr h="457200">
+              <a:tr h="0">
                 <a:tc>
                   <a:txBody>
                     <a:bodyPr/>
@@ -2372,17 +2358,17 @@
                         <a:buNone/>
                       </a:pPr>
                       <a:r>
-                        <a:rPr lang="en-US" sz="1050" b="1" dirty="0">
+                        <a:rPr lang="en-US" sz="1100" b="1" dirty="0">
                           <a:solidFill>
-                            <a:srgbClr val="202020"/>
+                            <a:srgbClr val="5B6072"/>
                           </a:solidFill>
                           <a:latin typeface="Calibri" pitchFamily="34" charset="0"/>
-                          <a:ea typeface="Calibri" pitchFamily="34" charset="-122"/>
-                          <a:cs typeface="Calibri" pitchFamily="34" charset="-120"/>
+                          <a:ea typeface="Calibri" pitchFamily="34"/>
+                          <a:cs typeface="Calibri" pitchFamily="34"/>
                         </a:rPr>
                         <a:t>Collect input</a:t>
                       </a:r>
-                      <a:endParaRPr lang="en-US" sz="1050" dirty="0">
+                      <a:endParaRPr lang="en-US" sz="1100" dirty="0">
                         <a:latin typeface="Calibri" charset="0"/>
                         <a:ea typeface="Calibri" charset="0"/>
                         <a:cs typeface="Calibri" charset="0"/>
@@ -2392,7 +2378,7 @@
                   <a:tcPr marL="91440" marR="91440" marT="45720" marB="45720" anchor="ctr">
                     <a:lnL w="9525" cap="flat" cmpd="sng" algn="ctr">
                       <a:solidFill>
-                        <a:srgbClr val="D9D9D9"/>
+                        <a:srgbClr val="D5D9E0"/>
                       </a:solidFill>
                       <a:prstDash val="solid"/>
                       <a:round/>
@@ -2401,7 +2387,7 @@
                     </a:lnL>
                     <a:lnR w="9525" cap="flat" cmpd="sng" algn="ctr">
                       <a:solidFill>
-                        <a:srgbClr val="D9D9D9"/>
+                        <a:srgbClr val="D5D9E0"/>
                       </a:solidFill>
                       <a:prstDash val="solid"/>
                       <a:round/>
@@ -2410,7 +2396,7 @@
                     </a:lnR>
                     <a:lnT w="9525" cap="flat" cmpd="sng" algn="ctr">
                       <a:solidFill>
-                        <a:srgbClr val="D9D9D9"/>
+                        <a:srgbClr val="D5D9E0"/>
                       </a:solidFill>
                       <a:prstDash val="solid"/>
                       <a:round/>
@@ -2419,7 +2405,7 @@
                     </a:lnT>
                     <a:lnB w="9525" cap="flat" cmpd="sng" algn="ctr">
                       <a:solidFill>
-                        <a:srgbClr val="D9D9D9"/>
+                        <a:srgbClr val="D5D9E0"/>
                       </a:solidFill>
                       <a:prstDash val="solid"/>
                       <a:round/>
@@ -2440,17 +2426,17 @@
                         <a:buNone/>
                       </a:pPr>
                       <a:r>
-                        <a:rPr lang="en-US" sz="1050" dirty="0">
+                        <a:rPr lang="en-US" sz="1100" dirty="0">
                           <a:solidFill>
-                            <a:srgbClr val="202020"/>
+                            <a:srgbClr val="1E2761"/>
                           </a:solidFill>
                           <a:latin typeface="Calibri" pitchFamily="34" charset="0"/>
-                          <a:ea typeface="Calibri" pitchFamily="34" charset="-122"/>
-                          <a:cs typeface="Calibri" pitchFamily="34" charset="-120"/>
+                          <a:ea typeface="Calibri" pitchFamily="34"/>
+                          <a:cs typeface="Calibri" pitchFamily="34"/>
                         </a:rPr>
                         <a:t>✓ Primary</a:t>
                       </a:r>
-                      <a:endParaRPr lang="en-US" sz="1050" dirty="0">
+                      <a:endParaRPr lang="en-US" sz="1100" dirty="0">
                         <a:latin typeface="Calibri" charset="0"/>
                         <a:ea typeface="Calibri" charset="0"/>
                         <a:cs typeface="Calibri" charset="0"/>
@@ -2460,7 +2446,7 @@
                   <a:tcPr marL="91440" marR="91440" marT="45720" marB="45720" anchor="ctr">
                     <a:lnL w="9525" cap="flat" cmpd="sng" algn="ctr">
                       <a:solidFill>
-                        <a:srgbClr val="D9D9D9"/>
+                        <a:srgbClr val="D5D9E0"/>
                       </a:solidFill>
                       <a:prstDash val="solid"/>
                       <a:round/>
@@ -2469,7 +2455,7 @@
                     </a:lnL>
                     <a:lnR w="9525" cap="flat" cmpd="sng" algn="ctr">
                       <a:solidFill>
-                        <a:srgbClr val="D9D9D9"/>
+                        <a:srgbClr val="D5D9E0"/>
                       </a:solidFill>
                       <a:prstDash val="solid"/>
                       <a:round/>
@@ -2478,7 +2464,7 @@
                     </a:lnR>
                     <a:lnT w="9525" cap="flat" cmpd="sng" algn="ctr">
                       <a:solidFill>
-                        <a:srgbClr val="D9D9D9"/>
+                        <a:srgbClr val="D5D9E0"/>
                       </a:solidFill>
                       <a:prstDash val="solid"/>
                       <a:round/>
@@ -2487,7 +2473,7 @@
                     </a:lnT>
                     <a:lnB w="9525" cap="flat" cmpd="sng" algn="ctr">
                       <a:solidFill>
-                        <a:srgbClr val="D9D9D9"/>
+                        <a:srgbClr val="D5D9E0"/>
                       </a:solidFill>
                       <a:prstDash val="solid"/>
                       <a:round/>
@@ -2508,17 +2494,17 @@
                         <a:buNone/>
                       </a:pPr>
                       <a:r>
-                        <a:rPr lang="en-US" sz="1050" dirty="0">
+                        <a:rPr lang="en-US" sz="1100" dirty="0">
                           <a:solidFill>
-                            <a:srgbClr val="202020"/>
+                            <a:srgbClr val="5B6072"/>
                           </a:solidFill>
                           <a:latin typeface="Calibri" pitchFamily="34" charset="0"/>
-                          <a:ea typeface="Calibri" pitchFamily="34" charset="-122"/>
-                          <a:cs typeface="Calibri" pitchFamily="34" charset="-120"/>
+                          <a:ea typeface="Calibri" pitchFamily="34"/>
+                          <a:cs typeface="Calibri" pitchFamily="34"/>
                         </a:rPr>
                         <a:t>—</a:t>
                       </a:r>
-                      <a:endParaRPr lang="en-US" sz="1050" dirty="0">
+                      <a:endParaRPr lang="en-US" sz="1100" dirty="0">
                         <a:latin typeface="Calibri" charset="0"/>
                         <a:ea typeface="Calibri" charset="0"/>
                         <a:cs typeface="Calibri" charset="0"/>
@@ -2528,7 +2514,7 @@
                   <a:tcPr marL="91440" marR="91440" marT="45720" marB="45720" anchor="ctr">
                     <a:lnL w="9525" cap="flat" cmpd="sng" algn="ctr">
                       <a:solidFill>
-                        <a:srgbClr val="D9D9D9"/>
+                        <a:srgbClr val="D5D9E0"/>
                       </a:solidFill>
                       <a:prstDash val="solid"/>
                       <a:round/>
@@ -2537,7 +2523,7 @@
                     </a:lnL>
                     <a:lnR w="9525" cap="flat" cmpd="sng" algn="ctr">
                       <a:solidFill>
-                        <a:srgbClr val="D9D9D9"/>
+                        <a:srgbClr val="D5D9E0"/>
                       </a:solidFill>
                       <a:prstDash val="solid"/>
                       <a:round/>
@@ -2546,7 +2532,7 @@
                     </a:lnR>
                     <a:lnT w="9525" cap="flat" cmpd="sng" algn="ctr">
                       <a:solidFill>
-                        <a:srgbClr val="D9D9D9"/>
+                        <a:srgbClr val="D5D9E0"/>
                       </a:solidFill>
                       <a:prstDash val="solid"/>
                       <a:round/>
@@ -2555,7 +2541,7 @@
                     </a:lnT>
                     <a:lnB w="9525" cap="flat" cmpd="sng" algn="ctr">
                       <a:solidFill>
-                        <a:srgbClr val="D9D9D9"/>
+                        <a:srgbClr val="D5D9E0"/>
                       </a:solidFill>
                       <a:prstDash val="solid"/>
                       <a:round/>
@@ -2576,17 +2562,17 @@
                         <a:buNone/>
                       </a:pPr>
                       <a:r>
-                        <a:rPr lang="en-US" sz="1050" dirty="0">
+                        <a:rPr lang="en-US" sz="1100" dirty="0">
                           <a:solidFill>
-                            <a:srgbClr val="202020"/>
+                            <a:srgbClr val="5B6072"/>
                           </a:solidFill>
                           <a:latin typeface="Calibri" pitchFamily="34" charset="0"/>
-                          <a:ea typeface="Calibri" pitchFamily="34" charset="-122"/>
-                          <a:cs typeface="Calibri" pitchFamily="34" charset="-120"/>
+                          <a:ea typeface="Calibri" pitchFamily="34"/>
+                          <a:cs typeface="Calibri" pitchFamily="34"/>
                         </a:rPr>
                         <a:t>—</a:t>
                       </a:r>
-                      <a:endParaRPr lang="en-US" sz="1050" dirty="0">
+                      <a:endParaRPr lang="en-US" sz="1100" dirty="0">
                         <a:latin typeface="Calibri" charset="0"/>
                         <a:ea typeface="Calibri" charset="0"/>
                         <a:cs typeface="Calibri" charset="0"/>
@@ -2596,7 +2582,7 @@
                   <a:tcPr marL="91440" marR="91440" marT="45720" marB="45720" anchor="ctr">
                     <a:lnL w="9525" cap="flat" cmpd="sng" algn="ctr">
                       <a:solidFill>
-                        <a:srgbClr val="D9D9D9"/>
+                        <a:srgbClr val="D5D9E0"/>
                       </a:solidFill>
                       <a:prstDash val="solid"/>
                       <a:round/>
@@ -2605,7 +2591,7 @@
                     </a:lnL>
                     <a:lnR w="9525" cap="flat" cmpd="sng" algn="ctr">
                       <a:solidFill>
-                        <a:srgbClr val="D9D9D9"/>
+                        <a:srgbClr val="D5D9E0"/>
                       </a:solidFill>
                       <a:prstDash val="solid"/>
                       <a:round/>
@@ -2614,7 +2600,7 @@
                     </a:lnR>
                     <a:lnT w="9525" cap="flat" cmpd="sng" algn="ctr">
                       <a:solidFill>
-                        <a:srgbClr val="D9D9D9"/>
+                        <a:srgbClr val="D5D9E0"/>
                       </a:solidFill>
                       <a:prstDash val="solid"/>
                       <a:round/>
@@ -2623,7 +2609,7 @@
                     </a:lnT>
                     <a:lnB w="9525" cap="flat" cmpd="sng" algn="ctr">
                       <a:solidFill>
-                        <a:srgbClr val="D9D9D9"/>
+                        <a:srgbClr val="D5D9E0"/>
                       </a:solidFill>
                       <a:prstDash val="solid"/>
                       <a:round/>
@@ -2636,7 +2622,7 @@
                   </a:tcPr>
                 </a:tc>
               </a:tr>
-              <a:tr h="457200">
+              <a:tr h="0">
                 <a:tc>
                   <a:txBody>
                     <a:bodyPr/>
@@ -2646,17 +2632,17 @@
                         <a:buNone/>
                       </a:pPr>
                       <a:r>
-                        <a:rPr lang="en-US" sz="1050" b="1" dirty="0">
+                        <a:rPr lang="en-US" sz="1100" b="1" dirty="0">
                           <a:solidFill>
-                            <a:srgbClr val="202020"/>
+                            <a:srgbClr val="5B6072"/>
                           </a:solidFill>
                           <a:latin typeface="Calibri" pitchFamily="34" charset="0"/>
-                          <a:ea typeface="Calibri" pitchFamily="34" charset="-122"/>
-                          <a:cs typeface="Calibri" pitchFamily="34" charset="-120"/>
+                          <a:ea typeface="Calibri" pitchFamily="34"/>
+                          <a:cs typeface="Calibri" pitchFamily="34"/>
                         </a:rPr>
                         <a:t>Immediate feedback</a:t>
                       </a:r>
-                      <a:endParaRPr lang="en-US" sz="1050" dirty="0">
+                      <a:endParaRPr lang="en-US" sz="1100" dirty="0">
                         <a:latin typeface="Calibri" charset="0"/>
                         <a:ea typeface="Calibri" charset="0"/>
                         <a:cs typeface="Calibri" charset="0"/>
@@ -2666,7 +2652,7 @@
                   <a:tcPr marL="91440" marR="91440" marT="45720" marB="45720" anchor="ctr">
                     <a:lnL w="9525" cap="flat" cmpd="sng" algn="ctr">
                       <a:solidFill>
-                        <a:srgbClr val="D9D9D9"/>
+                        <a:srgbClr val="D5D9E0"/>
                       </a:solidFill>
                       <a:prstDash val="solid"/>
                       <a:round/>
@@ -2675,7 +2661,7 @@
                     </a:lnL>
                     <a:lnR w="9525" cap="flat" cmpd="sng" algn="ctr">
                       <a:solidFill>
-                        <a:srgbClr val="D9D9D9"/>
+                        <a:srgbClr val="D5D9E0"/>
                       </a:solidFill>
                       <a:prstDash val="solid"/>
                       <a:round/>
@@ -2684,7 +2670,7 @@
                     </a:lnR>
                     <a:lnT w="9525" cap="flat" cmpd="sng" algn="ctr">
                       <a:solidFill>
-                        <a:srgbClr val="D9D9D9"/>
+                        <a:srgbClr val="D5D9E0"/>
                       </a:solidFill>
                       <a:prstDash val="solid"/>
                       <a:round/>
@@ -2693,7 +2679,7 @@
                     </a:lnT>
                     <a:lnB w="9525" cap="flat" cmpd="sng" algn="ctr">
                       <a:solidFill>
-                        <a:srgbClr val="D9D9D9"/>
+                        <a:srgbClr val="D5D9E0"/>
                       </a:solidFill>
                       <a:prstDash val="solid"/>
                       <a:round/>
@@ -2701,7 +2687,7 @@
                       <a:tailEnd type="none" w="med" len="med"/>
                     </a:lnB>
                     <a:solidFill>
-                      <a:srgbClr val="F4F6FC"/>
+                      <a:srgbClr val="F7F8FA"/>
                     </a:solidFill>
                   </a:tcPr>
                 </a:tc>
@@ -2714,17 +2700,17 @@
                         <a:buNone/>
                       </a:pPr>
                       <a:r>
-                        <a:rPr lang="en-US" sz="1050" dirty="0">
+                        <a:rPr lang="en-US" sz="1100" dirty="0">
                           <a:solidFill>
-                            <a:srgbClr val="202020"/>
+                            <a:srgbClr val="1E2761"/>
                           </a:solidFill>
                           <a:latin typeface="Calibri" pitchFamily="34" charset="0"/>
-                          <a:ea typeface="Calibri" pitchFamily="34" charset="-122"/>
-                          <a:cs typeface="Calibri" pitchFamily="34" charset="-120"/>
+                          <a:ea typeface="Calibri" pitchFamily="34"/>
+                          <a:cs typeface="Calibri" pitchFamily="34"/>
                         </a:rPr>
                         <a:t>✓ (client-side hints)</a:t>
                       </a:r>
-                      <a:endParaRPr lang="en-US" sz="1050" dirty="0">
+                      <a:endParaRPr lang="en-US" sz="1100" dirty="0">
                         <a:latin typeface="Calibri" charset="0"/>
                         <a:ea typeface="Calibri" charset="0"/>
                         <a:cs typeface="Calibri" charset="0"/>
@@ -2734,7 +2720,7 @@
                   <a:tcPr marL="91440" marR="91440" marT="45720" marB="45720" anchor="ctr">
                     <a:lnL w="9525" cap="flat" cmpd="sng" algn="ctr">
                       <a:solidFill>
-                        <a:srgbClr val="D9D9D9"/>
+                        <a:srgbClr val="D5D9E0"/>
                       </a:solidFill>
                       <a:prstDash val="solid"/>
                       <a:round/>
@@ -2743,7 +2729,7 @@
                     </a:lnL>
                     <a:lnR w="9525" cap="flat" cmpd="sng" algn="ctr">
                       <a:solidFill>
-                        <a:srgbClr val="D9D9D9"/>
+                        <a:srgbClr val="D5D9E0"/>
                       </a:solidFill>
                       <a:prstDash val="solid"/>
                       <a:round/>
@@ -2752,7 +2738,7 @@
                     </a:lnR>
                     <a:lnT w="9525" cap="flat" cmpd="sng" algn="ctr">
                       <a:solidFill>
-                        <a:srgbClr val="D9D9D9"/>
+                        <a:srgbClr val="D5D9E0"/>
                       </a:solidFill>
                       <a:prstDash val="solid"/>
                       <a:round/>
@@ -2761,7 +2747,7 @@
                     </a:lnT>
                     <a:lnB w="9525" cap="flat" cmpd="sng" algn="ctr">
                       <a:solidFill>
-                        <a:srgbClr val="D9D9D9"/>
+                        <a:srgbClr val="D5D9E0"/>
                       </a:solidFill>
                       <a:prstDash val="solid"/>
                       <a:round/>
@@ -2769,7 +2755,7 @@
                       <a:tailEnd type="none" w="med" len="med"/>
                     </a:lnB>
                     <a:solidFill>
-                      <a:srgbClr val="F4F6FC"/>
+                      <a:srgbClr val="F7F8FA"/>
                     </a:solidFill>
                   </a:tcPr>
                 </a:tc>
@@ -2782,17 +2768,17 @@
                         <a:buNone/>
                       </a:pPr>
                       <a:r>
-                        <a:rPr lang="en-US" sz="1050" dirty="0">
+                        <a:rPr lang="en-US" sz="1100" dirty="0">
                           <a:solidFill>
-                            <a:srgbClr val="202020"/>
+                            <a:srgbClr val="1E2761"/>
                           </a:solidFill>
                           <a:latin typeface="Calibri" pitchFamily="34" charset="0"/>
-                          <a:ea typeface="Calibri" pitchFamily="34" charset="-122"/>
-                          <a:cs typeface="Calibri" pitchFamily="34" charset="-120"/>
+                          <a:ea typeface="Calibri" pitchFamily="34"/>
+                          <a:cs typeface="Calibri" pitchFamily="34"/>
                         </a:rPr>
                         <a:t>✓ (confirms)</a:t>
                       </a:r>
-                      <a:endParaRPr lang="en-US" sz="1050" dirty="0">
+                      <a:endParaRPr lang="en-US" sz="1100" dirty="0">
                         <a:latin typeface="Calibri" charset="0"/>
                         <a:ea typeface="Calibri" charset="0"/>
                         <a:cs typeface="Calibri" charset="0"/>
@@ -2802,7 +2788,7 @@
                   <a:tcPr marL="91440" marR="91440" marT="45720" marB="45720" anchor="ctr">
                     <a:lnL w="9525" cap="flat" cmpd="sng" algn="ctr">
                       <a:solidFill>
-                        <a:srgbClr val="D9D9D9"/>
+                        <a:srgbClr val="D5D9E0"/>
                       </a:solidFill>
                       <a:prstDash val="solid"/>
                       <a:round/>
@@ -2811,7 +2797,7 @@
                     </a:lnL>
                     <a:lnR w="9525" cap="flat" cmpd="sng" algn="ctr">
                       <a:solidFill>
-                        <a:srgbClr val="D9D9D9"/>
+                        <a:srgbClr val="D5D9E0"/>
                       </a:solidFill>
                       <a:prstDash val="solid"/>
                       <a:round/>
@@ -2820,7 +2806,7 @@
                     </a:lnR>
                     <a:lnT w="9525" cap="flat" cmpd="sng" algn="ctr">
                       <a:solidFill>
-                        <a:srgbClr val="D9D9D9"/>
+                        <a:srgbClr val="D5D9E0"/>
                       </a:solidFill>
                       <a:prstDash val="solid"/>
                       <a:round/>
@@ -2829,7 +2815,7 @@
                     </a:lnT>
                     <a:lnB w="9525" cap="flat" cmpd="sng" algn="ctr">
                       <a:solidFill>
-                        <a:srgbClr val="D9D9D9"/>
+                        <a:srgbClr val="D5D9E0"/>
                       </a:solidFill>
                       <a:prstDash val="solid"/>
                       <a:round/>
@@ -2837,7 +2823,7 @@
                       <a:tailEnd type="none" w="med" len="med"/>
                     </a:lnB>
                     <a:solidFill>
-                      <a:srgbClr val="F4F6FC"/>
+                      <a:srgbClr val="F7F8FA"/>
                     </a:solidFill>
                   </a:tcPr>
                 </a:tc>
@@ -2850,17 +2836,17 @@
                         <a:buNone/>
                       </a:pPr>
                       <a:r>
-                        <a:rPr lang="en-US" sz="1050" dirty="0">
+                        <a:rPr lang="en-US" sz="1100" dirty="0">
                           <a:solidFill>
-                            <a:srgbClr val="202020"/>
+                            <a:srgbClr val="5B6072"/>
                           </a:solidFill>
                           <a:latin typeface="Calibri" pitchFamily="34" charset="0"/>
-                          <a:ea typeface="Calibri" pitchFamily="34" charset="-122"/>
-                          <a:cs typeface="Calibri" pitchFamily="34" charset="-120"/>
+                          <a:ea typeface="Calibri" pitchFamily="34"/>
+                          <a:cs typeface="Calibri" pitchFamily="34"/>
                         </a:rPr>
                         <a:t>—</a:t>
                       </a:r>
-                      <a:endParaRPr lang="en-US" sz="1050" dirty="0">
+                      <a:endParaRPr lang="en-US" sz="1100" dirty="0">
                         <a:latin typeface="Calibri" charset="0"/>
                         <a:ea typeface="Calibri" charset="0"/>
                         <a:cs typeface="Calibri" charset="0"/>
@@ -2870,7 +2856,7 @@
                   <a:tcPr marL="91440" marR="91440" marT="45720" marB="45720" anchor="ctr">
                     <a:lnL w="9525" cap="flat" cmpd="sng" algn="ctr">
                       <a:solidFill>
-                        <a:srgbClr val="D9D9D9"/>
+                        <a:srgbClr val="D5D9E0"/>
                       </a:solidFill>
                       <a:prstDash val="solid"/>
                       <a:round/>
@@ -2879,7 +2865,7 @@
                     </a:lnL>
                     <a:lnR w="9525" cap="flat" cmpd="sng" algn="ctr">
                       <a:solidFill>
-                        <a:srgbClr val="D9D9D9"/>
+                        <a:srgbClr val="D5D9E0"/>
                       </a:solidFill>
                       <a:prstDash val="solid"/>
                       <a:round/>
@@ -2888,7 +2874,7 @@
                     </a:lnR>
                     <a:lnT w="9525" cap="flat" cmpd="sng" algn="ctr">
                       <a:solidFill>
-                        <a:srgbClr val="D9D9D9"/>
+                        <a:srgbClr val="D5D9E0"/>
                       </a:solidFill>
                       <a:prstDash val="solid"/>
                       <a:round/>
@@ -2897,7 +2883,7 @@
                     </a:lnT>
                     <a:lnB w="9525" cap="flat" cmpd="sng" algn="ctr">
                       <a:solidFill>
-                        <a:srgbClr val="D9D9D9"/>
+                        <a:srgbClr val="D5D9E0"/>
                       </a:solidFill>
                       <a:prstDash val="solid"/>
                       <a:round/>
@@ -2905,12 +2891,12 @@
                       <a:tailEnd type="none" w="med" len="med"/>
                     </a:lnB>
                     <a:solidFill>
-                      <a:srgbClr val="F4F6FC"/>
+                      <a:srgbClr val="F7F8FA"/>
                     </a:solidFill>
                   </a:tcPr>
                 </a:tc>
               </a:tr>
-              <a:tr h="457200">
+              <a:tr h="0">
                 <a:tc>
                   <a:txBody>
                     <a:bodyPr/>
@@ -2920,17 +2906,17 @@
                         <a:buNone/>
                       </a:pPr>
                       <a:r>
-                        <a:rPr lang="en-US" sz="1050" b="1" dirty="0">
+                        <a:rPr lang="en-US" sz="1100" b="1" dirty="0">
                           <a:solidFill>
-                            <a:srgbClr val="202020"/>
+                            <a:srgbClr val="5B6072"/>
                           </a:solidFill>
                           <a:latin typeface="Calibri" pitchFamily="34" charset="0"/>
-                          <a:ea typeface="Calibri" pitchFamily="34" charset="-122"/>
-                          <a:cs typeface="Calibri" pitchFamily="34" charset="-120"/>
+                          <a:ea typeface="Calibri" pitchFamily="34"/>
+                          <a:cs typeface="Calibri" pitchFamily="34"/>
                         </a:rPr>
                         <a:t>Critical validation</a:t>
                       </a:r>
-                      <a:endParaRPr lang="en-US" sz="1050" dirty="0">
+                      <a:endParaRPr lang="en-US" sz="1100" dirty="0">
                         <a:latin typeface="Calibri" charset="0"/>
                         <a:ea typeface="Calibri" charset="0"/>
                         <a:cs typeface="Calibri" charset="0"/>
@@ -2940,7 +2926,7 @@
                   <a:tcPr marL="91440" marR="91440" marT="45720" marB="45720" anchor="ctr">
                     <a:lnL w="9525" cap="flat" cmpd="sng" algn="ctr">
                       <a:solidFill>
-                        <a:srgbClr val="D9D9D9"/>
+                        <a:srgbClr val="D5D9E0"/>
                       </a:solidFill>
                       <a:prstDash val="solid"/>
                       <a:round/>
@@ -2949,7 +2935,7 @@
                     </a:lnL>
                     <a:lnR w="9525" cap="flat" cmpd="sng" algn="ctr">
                       <a:solidFill>
-                        <a:srgbClr val="D9D9D9"/>
+                        <a:srgbClr val="D5D9E0"/>
                       </a:solidFill>
                       <a:prstDash val="solid"/>
                       <a:round/>
@@ -2958,7 +2944,7 @@
                     </a:lnR>
                     <a:lnT w="9525" cap="flat" cmpd="sng" algn="ctr">
                       <a:solidFill>
-                        <a:srgbClr val="D9D9D9"/>
+                        <a:srgbClr val="D5D9E0"/>
                       </a:solidFill>
                       <a:prstDash val="solid"/>
                       <a:round/>
@@ -2967,7 +2953,7 @@
                     </a:lnT>
                     <a:lnB w="9525" cap="flat" cmpd="sng" algn="ctr">
                       <a:solidFill>
-                        <a:srgbClr val="D9D9D9"/>
+                        <a:srgbClr val="D5D9E0"/>
                       </a:solidFill>
                       <a:prstDash val="solid"/>
                       <a:round/>
@@ -2988,17 +2974,17 @@
                         <a:buNone/>
                       </a:pPr>
                       <a:r>
-                        <a:rPr lang="en-US" sz="1050" dirty="0">
+                        <a:rPr lang="en-US" sz="1100" dirty="0">
                           <a:solidFill>
-                            <a:srgbClr val="202020"/>
+                            <a:srgbClr val="5B6072"/>
                           </a:solidFill>
                           <a:latin typeface="Calibri" pitchFamily="34" charset="0"/>
-                          <a:ea typeface="Calibri" pitchFamily="34" charset="-122"/>
-                          <a:cs typeface="Calibri" pitchFamily="34" charset="-120"/>
+                          <a:ea typeface="Calibri" pitchFamily="34"/>
+                          <a:cs typeface="Calibri" pitchFamily="34"/>
                         </a:rPr>
                         <a:t>— (convenience only)</a:t>
                       </a:r>
-                      <a:endParaRPr lang="en-US" sz="1050" dirty="0">
+                      <a:endParaRPr lang="en-US" sz="1100" dirty="0">
                         <a:latin typeface="Calibri" charset="0"/>
                         <a:ea typeface="Calibri" charset="0"/>
                         <a:cs typeface="Calibri" charset="0"/>
@@ -3008,7 +2994,7 @@
                   <a:tcPr marL="91440" marR="91440" marT="45720" marB="45720" anchor="ctr">
                     <a:lnL w="9525" cap="flat" cmpd="sng" algn="ctr">
                       <a:solidFill>
-                        <a:srgbClr val="D9D9D9"/>
+                        <a:srgbClr val="D5D9E0"/>
                       </a:solidFill>
                       <a:prstDash val="solid"/>
                       <a:round/>
@@ -3017,7 +3003,7 @@
                     </a:lnL>
                     <a:lnR w="9525" cap="flat" cmpd="sng" algn="ctr">
                       <a:solidFill>
-                        <a:srgbClr val="D9D9D9"/>
+                        <a:srgbClr val="D5D9E0"/>
                       </a:solidFill>
                       <a:prstDash val="solid"/>
                       <a:round/>
@@ -3026,7 +3012,7 @@
                     </a:lnR>
                     <a:lnT w="9525" cap="flat" cmpd="sng" algn="ctr">
                       <a:solidFill>
-                        <a:srgbClr val="D9D9D9"/>
+                        <a:srgbClr val="D5D9E0"/>
                       </a:solidFill>
                       <a:prstDash val="solid"/>
                       <a:round/>
@@ -3035,7 +3021,7 @@
                     </a:lnT>
                     <a:lnB w="9525" cap="flat" cmpd="sng" algn="ctr">
                       <a:solidFill>
-                        <a:srgbClr val="D9D9D9"/>
+                        <a:srgbClr val="D5D9E0"/>
                       </a:solidFill>
                       <a:prstDash val="solid"/>
                       <a:round/>
@@ -3056,17 +3042,17 @@
                         <a:buNone/>
                       </a:pPr>
                       <a:r>
-                        <a:rPr lang="en-US" sz="1050" dirty="0">
+                        <a:rPr lang="en-US" sz="1100" dirty="0">
                           <a:solidFill>
-                            <a:srgbClr val="202020"/>
+                            <a:srgbClr val="1E2761"/>
                           </a:solidFill>
                           <a:latin typeface="Calibri" pitchFamily="34" charset="0"/>
-                          <a:ea typeface="Calibri" pitchFamily="34" charset="-122"/>
-                          <a:cs typeface="Calibri" pitchFamily="34" charset="-120"/>
+                          <a:ea typeface="Calibri" pitchFamily="34"/>
+                          <a:cs typeface="Calibri" pitchFamily="34"/>
                         </a:rPr>
                         <a:t>✓ Authoritative</a:t>
                       </a:r>
-                      <a:endParaRPr lang="en-US" sz="1050" dirty="0">
+                      <a:endParaRPr lang="en-US" sz="1100" dirty="0">
                         <a:latin typeface="Calibri" charset="0"/>
                         <a:ea typeface="Calibri" charset="0"/>
                         <a:cs typeface="Calibri" charset="0"/>
@@ -3076,7 +3062,7 @@
                   <a:tcPr marL="91440" marR="91440" marT="45720" marB="45720" anchor="ctr">
                     <a:lnL w="9525" cap="flat" cmpd="sng" algn="ctr">
                       <a:solidFill>
-                        <a:srgbClr val="D9D9D9"/>
+                        <a:srgbClr val="D5D9E0"/>
                       </a:solidFill>
                       <a:prstDash val="solid"/>
                       <a:round/>
@@ -3085,7 +3071,7 @@
                     </a:lnL>
                     <a:lnR w="9525" cap="flat" cmpd="sng" algn="ctr">
                       <a:solidFill>
-                        <a:srgbClr val="D9D9D9"/>
+                        <a:srgbClr val="D5D9E0"/>
                       </a:solidFill>
                       <a:prstDash val="solid"/>
                       <a:round/>
@@ -3094,7 +3080,7 @@
                     </a:lnR>
                     <a:lnT w="9525" cap="flat" cmpd="sng" algn="ctr">
                       <a:solidFill>
-                        <a:srgbClr val="D9D9D9"/>
+                        <a:srgbClr val="D5D9E0"/>
                       </a:solidFill>
                       <a:prstDash val="solid"/>
                       <a:round/>
@@ -3103,7 +3089,7 @@
                     </a:lnT>
                     <a:lnB w="9525" cap="flat" cmpd="sng" algn="ctr">
                       <a:solidFill>
-                        <a:srgbClr val="D9D9D9"/>
+                        <a:srgbClr val="D5D9E0"/>
                       </a:solidFill>
                       <a:prstDash val="solid"/>
                       <a:round/>
@@ -3124,17 +3110,17 @@
                         <a:buNone/>
                       </a:pPr>
                       <a:r>
-                        <a:rPr lang="en-US" sz="1050" dirty="0">
+                        <a:rPr lang="en-US" sz="1100" dirty="0">
                           <a:solidFill>
-                            <a:srgbClr val="202020"/>
+                            <a:srgbClr val="5B6072"/>
                           </a:solidFill>
                           <a:latin typeface="Calibri" pitchFamily="34" charset="0"/>
-                          <a:ea typeface="Calibri" pitchFamily="34" charset="-122"/>
-                          <a:cs typeface="Calibri" pitchFamily="34" charset="-120"/>
+                          <a:ea typeface="Calibri" pitchFamily="34"/>
+                          <a:cs typeface="Calibri" pitchFamily="34"/>
                         </a:rPr>
                         <a:t>—</a:t>
                       </a:r>
-                      <a:endParaRPr lang="en-US" sz="1050" dirty="0">
+                      <a:endParaRPr lang="en-US" sz="1100" dirty="0">
                         <a:latin typeface="Calibri" charset="0"/>
                         <a:ea typeface="Calibri" charset="0"/>
                         <a:cs typeface="Calibri" charset="0"/>
@@ -3144,7 +3130,7 @@
                   <a:tcPr marL="91440" marR="91440" marT="45720" marB="45720" anchor="ctr">
                     <a:lnL w="9525" cap="flat" cmpd="sng" algn="ctr">
                       <a:solidFill>
-                        <a:srgbClr val="D9D9D9"/>
+                        <a:srgbClr val="D5D9E0"/>
                       </a:solidFill>
                       <a:prstDash val="solid"/>
                       <a:round/>
@@ -3153,7 +3139,7 @@
                     </a:lnL>
                     <a:lnR w="9525" cap="flat" cmpd="sng" algn="ctr">
                       <a:solidFill>
-                        <a:srgbClr val="D9D9D9"/>
+                        <a:srgbClr val="D5D9E0"/>
                       </a:solidFill>
                       <a:prstDash val="solid"/>
                       <a:round/>
@@ -3162,7 +3148,7 @@
                     </a:lnR>
                     <a:lnT w="9525" cap="flat" cmpd="sng" algn="ctr">
                       <a:solidFill>
-                        <a:srgbClr val="D9D9D9"/>
+                        <a:srgbClr val="D5D9E0"/>
                       </a:solidFill>
                       <a:prstDash val="solid"/>
                       <a:round/>
@@ -3171,7 +3157,7 @@
                     </a:lnT>
                     <a:lnB w="9525" cap="flat" cmpd="sng" algn="ctr">
                       <a:solidFill>
-                        <a:srgbClr val="D9D9D9"/>
+                        <a:srgbClr val="D5D9E0"/>
                       </a:solidFill>
                       <a:prstDash val="solid"/>
                       <a:round/>
@@ -3184,7 +3170,7 @@
                   </a:tcPr>
                 </a:tc>
               </a:tr>
-              <a:tr h="457200">
+              <a:tr h="0">
                 <a:tc>
                   <a:txBody>
                     <a:bodyPr/>
@@ -3194,17 +3180,17 @@
                         <a:buNone/>
                       </a:pPr>
                       <a:r>
-                        <a:rPr lang="en-US" sz="1050" b="1" dirty="0">
+                        <a:rPr lang="en-US" sz="1100" b="1" dirty="0">
                           <a:solidFill>
-                            <a:srgbClr val="202020"/>
+                            <a:srgbClr val="5B6072"/>
                           </a:solidFill>
                           <a:latin typeface="Calibri" pitchFamily="34" charset="0"/>
-                          <a:ea typeface="Calibri" pitchFamily="34" charset="-122"/>
-                          <a:cs typeface="Calibri" pitchFamily="34" charset="-120"/>
+                          <a:ea typeface="Calibri" pitchFamily="34"/>
+                          <a:cs typeface="Calibri" pitchFamily="34"/>
                         </a:rPr>
                         <a:t>Business rules</a:t>
                       </a:r>
-                      <a:endParaRPr lang="en-US" sz="1050" dirty="0">
+                      <a:endParaRPr lang="en-US" sz="1100" dirty="0">
                         <a:latin typeface="Calibri" charset="0"/>
                         <a:ea typeface="Calibri" charset="0"/>
                         <a:cs typeface="Calibri" charset="0"/>
@@ -3214,7 +3200,7 @@
                   <a:tcPr marL="91440" marR="91440" marT="45720" marB="45720" anchor="ctr">
                     <a:lnL w="9525" cap="flat" cmpd="sng" algn="ctr">
                       <a:solidFill>
-                        <a:srgbClr val="D9D9D9"/>
+                        <a:srgbClr val="D5D9E0"/>
                       </a:solidFill>
                       <a:prstDash val="solid"/>
                       <a:round/>
@@ -3223,7 +3209,7 @@
                     </a:lnL>
                     <a:lnR w="9525" cap="flat" cmpd="sng" algn="ctr">
                       <a:solidFill>
-                        <a:srgbClr val="D9D9D9"/>
+                        <a:srgbClr val="D5D9E0"/>
                       </a:solidFill>
                       <a:prstDash val="solid"/>
                       <a:round/>
@@ -3232,7 +3218,7 @@
                     </a:lnR>
                     <a:lnT w="9525" cap="flat" cmpd="sng" algn="ctr">
                       <a:solidFill>
-                        <a:srgbClr val="D9D9D9"/>
+                        <a:srgbClr val="D5D9E0"/>
                       </a:solidFill>
                       <a:prstDash val="solid"/>
                       <a:round/>
@@ -3241,7 +3227,7 @@
                     </a:lnT>
                     <a:lnB w="9525" cap="flat" cmpd="sng" algn="ctr">
                       <a:solidFill>
-                        <a:srgbClr val="D9D9D9"/>
+                        <a:srgbClr val="D5D9E0"/>
                       </a:solidFill>
                       <a:prstDash val="solid"/>
                       <a:round/>
@@ -3249,7 +3235,7 @@
                       <a:tailEnd type="none" w="med" len="med"/>
                     </a:lnB>
                     <a:solidFill>
-                      <a:srgbClr val="F4F6FC"/>
+                      <a:srgbClr val="F7F8FA"/>
                     </a:solidFill>
                   </a:tcPr>
                 </a:tc>
@@ -3262,17 +3248,17 @@
                         <a:buNone/>
                       </a:pPr>
                       <a:r>
-                        <a:rPr lang="en-US" sz="1050" dirty="0">
+                        <a:rPr lang="en-US" sz="1100" dirty="0">
                           <a:solidFill>
-                            <a:srgbClr val="202020"/>
+                            <a:srgbClr val="5B6072"/>
                           </a:solidFill>
                           <a:latin typeface="Calibri" pitchFamily="34" charset="0"/>
-                          <a:ea typeface="Calibri" pitchFamily="34" charset="-122"/>
-                          <a:cs typeface="Calibri" pitchFamily="34" charset="-120"/>
+                          <a:ea typeface="Calibri" pitchFamily="34"/>
+                          <a:cs typeface="Calibri" pitchFamily="34"/>
                         </a:rPr>
                         <a:t>—</a:t>
                       </a:r>
-                      <a:endParaRPr lang="en-US" sz="1050" dirty="0">
+                      <a:endParaRPr lang="en-US" sz="1100" dirty="0">
                         <a:latin typeface="Calibri" charset="0"/>
                         <a:ea typeface="Calibri" charset="0"/>
                         <a:cs typeface="Calibri" charset="0"/>
@@ -3282,7 +3268,7 @@
                   <a:tcPr marL="91440" marR="91440" marT="45720" marB="45720" anchor="ctr">
                     <a:lnL w="9525" cap="flat" cmpd="sng" algn="ctr">
                       <a:solidFill>
-                        <a:srgbClr val="D9D9D9"/>
+                        <a:srgbClr val="D5D9E0"/>
                       </a:solidFill>
                       <a:prstDash val="solid"/>
                       <a:round/>
@@ -3291,7 +3277,7 @@
                     </a:lnL>
                     <a:lnR w="9525" cap="flat" cmpd="sng" algn="ctr">
                       <a:solidFill>
-                        <a:srgbClr val="D9D9D9"/>
+                        <a:srgbClr val="D5D9E0"/>
                       </a:solidFill>
                       <a:prstDash val="solid"/>
                       <a:round/>
@@ -3300,7 +3286,7 @@
                     </a:lnR>
                     <a:lnT w="9525" cap="flat" cmpd="sng" algn="ctr">
                       <a:solidFill>
-                        <a:srgbClr val="D9D9D9"/>
+                        <a:srgbClr val="D5D9E0"/>
                       </a:solidFill>
                       <a:prstDash val="solid"/>
                       <a:round/>
@@ -3309,7 +3295,7 @@
                     </a:lnT>
                     <a:lnB w="9525" cap="flat" cmpd="sng" algn="ctr">
                       <a:solidFill>
-                        <a:srgbClr val="D9D9D9"/>
+                        <a:srgbClr val="D5D9E0"/>
                       </a:solidFill>
                       <a:prstDash val="solid"/>
                       <a:round/>
@@ -3317,7 +3303,7 @@
                       <a:tailEnd type="none" w="med" len="med"/>
                     </a:lnB>
                     <a:solidFill>
-                      <a:srgbClr val="F4F6FC"/>
+                      <a:srgbClr val="F7F8FA"/>
                     </a:solidFill>
                   </a:tcPr>
                 </a:tc>
@@ -3330,17 +3316,17 @@
                         <a:buNone/>
                       </a:pPr>
                       <a:r>
-                        <a:rPr lang="en-US" sz="1050" dirty="0">
+                        <a:rPr lang="en-US" sz="1100" dirty="0">
                           <a:solidFill>
-                            <a:srgbClr val="202020"/>
+                            <a:srgbClr val="1E2761"/>
                           </a:solidFill>
                           <a:latin typeface="Calibri" pitchFamily="34" charset="0"/>
-                          <a:ea typeface="Calibri" pitchFamily="34" charset="-122"/>
-                          <a:cs typeface="Calibri" pitchFamily="34" charset="-120"/>
+                          <a:ea typeface="Calibri" pitchFamily="34"/>
+                          <a:cs typeface="Calibri" pitchFamily="34"/>
                         </a:rPr>
                         <a:t>✓ Owns all business rules</a:t>
                       </a:r>
-                      <a:endParaRPr lang="en-US" sz="1050" dirty="0">
+                      <a:endParaRPr lang="en-US" sz="1100" dirty="0">
                         <a:latin typeface="Calibri" charset="0"/>
                         <a:ea typeface="Calibri" charset="0"/>
                         <a:cs typeface="Calibri" charset="0"/>
@@ -3350,7 +3336,7 @@
                   <a:tcPr marL="91440" marR="91440" marT="45720" marB="45720" anchor="ctr">
                     <a:lnL w="9525" cap="flat" cmpd="sng" algn="ctr">
                       <a:solidFill>
-                        <a:srgbClr val="D9D9D9"/>
+                        <a:srgbClr val="D5D9E0"/>
                       </a:solidFill>
                       <a:prstDash val="solid"/>
                       <a:round/>
@@ -3359,7 +3345,7 @@
                     </a:lnL>
                     <a:lnR w="9525" cap="flat" cmpd="sng" algn="ctr">
                       <a:solidFill>
-                        <a:srgbClr val="D9D9D9"/>
+                        <a:srgbClr val="D5D9E0"/>
                       </a:solidFill>
                       <a:prstDash val="solid"/>
                       <a:round/>
@@ -3368,7 +3354,7 @@
                     </a:lnR>
                     <a:lnT w="9525" cap="flat" cmpd="sng" algn="ctr">
                       <a:solidFill>
-                        <a:srgbClr val="D9D9D9"/>
+                        <a:srgbClr val="D5D9E0"/>
                       </a:solidFill>
                       <a:prstDash val="solid"/>
                       <a:round/>
@@ -3377,7 +3363,7 @@
                     </a:lnT>
                     <a:lnB w="9525" cap="flat" cmpd="sng" algn="ctr">
                       <a:solidFill>
-                        <a:srgbClr val="D9D9D9"/>
+                        <a:srgbClr val="D5D9E0"/>
                       </a:solidFill>
                       <a:prstDash val="solid"/>
                       <a:round/>
@@ -3385,7 +3371,7 @@
                       <a:tailEnd type="none" w="med" len="med"/>
                     </a:lnB>
                     <a:solidFill>
-                      <a:srgbClr val="F4F6FC"/>
+                      <a:srgbClr val="F7F8FA"/>
                     </a:solidFill>
                   </a:tcPr>
                 </a:tc>
@@ -3398,17 +3384,17 @@
                         <a:buNone/>
                       </a:pPr>
                       <a:r>
-                        <a:rPr lang="en-US" sz="1050" dirty="0">
+                        <a:rPr lang="en-US" sz="1100" dirty="0">
                           <a:solidFill>
-                            <a:srgbClr val="202020"/>
+                            <a:srgbClr val="5B6072"/>
                           </a:solidFill>
                           <a:latin typeface="Calibri" pitchFamily="34" charset="0"/>
-                          <a:ea typeface="Calibri" pitchFamily="34" charset="-122"/>
-                          <a:cs typeface="Calibri" pitchFamily="34" charset="-120"/>
+                          <a:ea typeface="Calibri" pitchFamily="34"/>
+                          <a:cs typeface="Calibri" pitchFamily="34"/>
                         </a:rPr>
                         <a:t>—</a:t>
                       </a:r>
-                      <a:endParaRPr lang="en-US" sz="1050" dirty="0">
+                      <a:endParaRPr lang="en-US" sz="1100" dirty="0">
                         <a:latin typeface="Calibri" charset="0"/>
                         <a:ea typeface="Calibri" charset="0"/>
                         <a:cs typeface="Calibri" charset="0"/>
@@ -3418,7 +3404,7 @@
                   <a:tcPr marL="91440" marR="91440" marT="45720" marB="45720" anchor="ctr">
                     <a:lnL w="9525" cap="flat" cmpd="sng" algn="ctr">
                       <a:solidFill>
-                        <a:srgbClr val="D9D9D9"/>
+                        <a:srgbClr val="D5D9E0"/>
                       </a:solidFill>
                       <a:prstDash val="solid"/>
                       <a:round/>
@@ -3427,7 +3413,7 @@
                     </a:lnL>
                     <a:lnR w="9525" cap="flat" cmpd="sng" algn="ctr">
                       <a:solidFill>
-                        <a:srgbClr val="D9D9D9"/>
+                        <a:srgbClr val="D5D9E0"/>
                       </a:solidFill>
                       <a:prstDash val="solid"/>
                       <a:round/>
@@ -3436,7 +3422,7 @@
                     </a:lnR>
                     <a:lnT w="9525" cap="flat" cmpd="sng" algn="ctr">
                       <a:solidFill>
-                        <a:srgbClr val="D9D9D9"/>
+                        <a:srgbClr val="D5D9E0"/>
                       </a:solidFill>
                       <a:prstDash val="solid"/>
                       <a:round/>
@@ -3445,7 +3431,7 @@
                     </a:lnT>
                     <a:lnB w="9525" cap="flat" cmpd="sng" algn="ctr">
                       <a:solidFill>
-                        <a:srgbClr val="D9D9D9"/>
+                        <a:srgbClr val="D5D9E0"/>
                       </a:solidFill>
                       <a:prstDash val="solid"/>
                       <a:round/>
@@ -3453,12 +3439,12 @@
                       <a:tailEnd type="none" w="med" len="med"/>
                     </a:lnB>
                     <a:solidFill>
-                      <a:srgbClr val="F4F6FC"/>
+                      <a:srgbClr val="F7F8FA"/>
                     </a:solidFill>
                   </a:tcPr>
                 </a:tc>
               </a:tr>
-              <a:tr h="457200">
+              <a:tr h="0">
                 <a:tc>
                   <a:txBody>
                     <a:bodyPr/>
@@ -3468,17 +3454,17 @@
                         <a:buNone/>
                       </a:pPr>
                       <a:r>
-                        <a:rPr lang="en-US" sz="1050" b="1" dirty="0">
+                        <a:rPr lang="en-US" sz="1100" b="1" dirty="0">
                           <a:solidFill>
-                            <a:srgbClr val="202020"/>
+                            <a:srgbClr val="5B6072"/>
                           </a:solidFill>
                           <a:latin typeface="Calibri" pitchFamily="34" charset="0"/>
-                          <a:ea typeface="Calibri" pitchFamily="34" charset="-122"/>
-                          <a:cs typeface="Calibri" pitchFamily="34" charset="-120"/>
+                          <a:ea typeface="Calibri" pitchFamily="34"/>
+                          <a:cs typeface="Calibri" pitchFamily="34"/>
                         </a:rPr>
                         <a:t>State transition</a:t>
                       </a:r>
-                      <a:endParaRPr lang="en-US" sz="1050" dirty="0">
+                      <a:endParaRPr lang="en-US" sz="1100" dirty="0">
                         <a:latin typeface="Calibri" charset="0"/>
                         <a:ea typeface="Calibri" charset="0"/>
                         <a:cs typeface="Calibri" charset="0"/>
@@ -3488,7 +3474,7 @@
                   <a:tcPr marL="91440" marR="91440" marT="45720" marB="45720" anchor="ctr">
                     <a:lnL w="9525" cap="flat" cmpd="sng" algn="ctr">
                       <a:solidFill>
-                        <a:srgbClr val="D9D9D9"/>
+                        <a:srgbClr val="D5D9E0"/>
                       </a:solidFill>
                       <a:prstDash val="solid"/>
                       <a:round/>
@@ -3497,7 +3483,7 @@
                     </a:lnL>
                     <a:lnR w="9525" cap="flat" cmpd="sng" algn="ctr">
                       <a:solidFill>
-                        <a:srgbClr val="D9D9D9"/>
+                        <a:srgbClr val="D5D9E0"/>
                       </a:solidFill>
                       <a:prstDash val="solid"/>
                       <a:round/>
@@ -3506,7 +3492,7 @@
                     </a:lnR>
                     <a:lnT w="9525" cap="flat" cmpd="sng" algn="ctr">
                       <a:solidFill>
-                        <a:srgbClr val="D9D9D9"/>
+                        <a:srgbClr val="D5D9E0"/>
                       </a:solidFill>
                       <a:prstDash val="solid"/>
                       <a:round/>
@@ -3515,7 +3501,7 @@
                     </a:lnT>
                     <a:lnB w="9525" cap="flat" cmpd="sng" algn="ctr">
                       <a:solidFill>
-                        <a:srgbClr val="D9D9D9"/>
+                        <a:srgbClr val="D5D9E0"/>
                       </a:solidFill>
                       <a:prstDash val="solid"/>
                       <a:round/>
@@ -3536,17 +3522,17 @@
                         <a:buNone/>
                       </a:pPr>
                       <a:r>
-                        <a:rPr lang="en-US" sz="1050" dirty="0">
+                        <a:rPr lang="en-US" sz="1100" dirty="0">
                           <a:solidFill>
-                            <a:srgbClr val="202020"/>
+                            <a:srgbClr val="5B6072"/>
                           </a:solidFill>
                           <a:latin typeface="Calibri" pitchFamily="34" charset="0"/>
-                          <a:ea typeface="Calibri" pitchFamily="34" charset="-122"/>
-                          <a:cs typeface="Calibri" pitchFamily="34" charset="-120"/>
+                          <a:ea typeface="Calibri" pitchFamily="34"/>
+                          <a:cs typeface="Calibri" pitchFamily="34"/>
                         </a:rPr>
                         <a:t>—</a:t>
                       </a:r>
-                      <a:endParaRPr lang="en-US" sz="1050" dirty="0">
+                      <a:endParaRPr lang="en-US" sz="1100" dirty="0">
                         <a:latin typeface="Calibri" charset="0"/>
                         <a:ea typeface="Calibri" charset="0"/>
                         <a:cs typeface="Calibri" charset="0"/>
@@ -3556,7 +3542,7 @@
                   <a:tcPr marL="91440" marR="91440" marT="45720" marB="45720" anchor="ctr">
                     <a:lnL w="9525" cap="flat" cmpd="sng" algn="ctr">
                       <a:solidFill>
-                        <a:srgbClr val="D9D9D9"/>
+                        <a:srgbClr val="D5D9E0"/>
                       </a:solidFill>
                       <a:prstDash val="solid"/>
                       <a:round/>
@@ -3565,7 +3551,7 @@
                     </a:lnL>
                     <a:lnR w="9525" cap="flat" cmpd="sng" algn="ctr">
                       <a:solidFill>
-                        <a:srgbClr val="D9D9D9"/>
+                        <a:srgbClr val="D5D9E0"/>
                       </a:solidFill>
                       <a:prstDash val="solid"/>
                       <a:round/>
@@ -3574,7 +3560,7 @@
                     </a:lnR>
                     <a:lnT w="9525" cap="flat" cmpd="sng" algn="ctr">
                       <a:solidFill>
-                        <a:srgbClr val="D9D9D9"/>
+                        <a:srgbClr val="D5D9E0"/>
                       </a:solidFill>
                       <a:prstDash val="solid"/>
                       <a:round/>
@@ -3583,7 +3569,7 @@
                     </a:lnT>
                     <a:lnB w="9525" cap="flat" cmpd="sng" algn="ctr">
                       <a:solidFill>
-                        <a:srgbClr val="D9D9D9"/>
+                        <a:srgbClr val="D5D9E0"/>
                       </a:solidFill>
                       <a:prstDash val="solid"/>
                       <a:round/>
@@ -3604,17 +3590,17 @@
                         <a:buNone/>
                       </a:pPr>
                       <a:r>
-                        <a:rPr lang="en-US" sz="1050" dirty="0">
+                        <a:rPr lang="en-US" sz="1100" dirty="0">
                           <a:solidFill>
-                            <a:srgbClr val="202020"/>
+                            <a:srgbClr val="1E2761"/>
                           </a:solidFill>
                           <a:latin typeface="Calibri" pitchFamily="34" charset="0"/>
-                          <a:ea typeface="Calibri" pitchFamily="34" charset="-122"/>
-                          <a:cs typeface="Calibri" pitchFamily="34" charset="-120"/>
+                          <a:ea typeface="Calibri" pitchFamily="34"/>
+                          <a:cs typeface="Calibri" pitchFamily="34"/>
                         </a:rPr>
                         <a:t>✓ Owns transition logic</a:t>
                       </a:r>
-                      <a:endParaRPr lang="en-US" sz="1050" dirty="0">
+                      <a:endParaRPr lang="en-US" sz="1100" dirty="0">
                         <a:latin typeface="Calibri" charset="0"/>
                         <a:ea typeface="Calibri" charset="0"/>
                         <a:cs typeface="Calibri" charset="0"/>
@@ -3624,7 +3610,7 @@
                   <a:tcPr marL="91440" marR="91440" marT="45720" marB="45720" anchor="ctr">
                     <a:lnL w="9525" cap="flat" cmpd="sng" algn="ctr">
                       <a:solidFill>
-                        <a:srgbClr val="D9D9D9"/>
+                        <a:srgbClr val="D5D9E0"/>
                       </a:solidFill>
                       <a:prstDash val="solid"/>
                       <a:round/>
@@ -3633,7 +3619,7 @@
                     </a:lnL>
                     <a:lnR w="9525" cap="flat" cmpd="sng" algn="ctr">
                       <a:solidFill>
-                        <a:srgbClr val="D9D9D9"/>
+                        <a:srgbClr val="D5D9E0"/>
                       </a:solidFill>
                       <a:prstDash val="solid"/>
                       <a:round/>
@@ -3642,7 +3628,7 @@
                     </a:lnR>
                     <a:lnT w="9525" cap="flat" cmpd="sng" algn="ctr">
                       <a:solidFill>
-                        <a:srgbClr val="D9D9D9"/>
+                        <a:srgbClr val="D5D9E0"/>
                       </a:solidFill>
                       <a:prstDash val="solid"/>
                       <a:round/>
@@ -3651,7 +3637,7 @@
                     </a:lnT>
                     <a:lnB w="9525" cap="flat" cmpd="sng" algn="ctr">
                       <a:solidFill>
-                        <a:srgbClr val="D9D9D9"/>
+                        <a:srgbClr val="D5D9E0"/>
                       </a:solidFill>
                       <a:prstDash val="solid"/>
                       <a:round/>
@@ -3672,17 +3658,17 @@
                         <a:buNone/>
                       </a:pPr>
                       <a:r>
-                        <a:rPr lang="en-US" sz="1050" dirty="0">
+                        <a:rPr lang="en-US" sz="1100" dirty="0">
                           <a:solidFill>
-                            <a:srgbClr val="202020"/>
+                            <a:srgbClr val="1E2761"/>
                           </a:solidFill>
                           <a:latin typeface="Calibri" pitchFamily="34" charset="0"/>
-                          <a:ea typeface="Calibri" pitchFamily="34" charset="-122"/>
-                          <a:cs typeface="Calibri" pitchFamily="34" charset="-120"/>
+                          <a:ea typeface="Calibri" pitchFamily="34"/>
+                          <a:cs typeface="Calibri" pitchFamily="34"/>
                         </a:rPr>
                         <a:t>✓ Persists resulting state</a:t>
                       </a:r>
-                      <a:endParaRPr lang="en-US" sz="1050" dirty="0">
+                      <a:endParaRPr lang="en-US" sz="1100" dirty="0">
                         <a:latin typeface="Calibri" charset="0"/>
                         <a:ea typeface="Calibri" charset="0"/>
                         <a:cs typeface="Calibri" charset="0"/>
@@ -3692,7 +3678,7 @@
                   <a:tcPr marL="91440" marR="91440" marT="45720" marB="45720" anchor="ctr">
                     <a:lnL w="9525" cap="flat" cmpd="sng" algn="ctr">
                       <a:solidFill>
-                        <a:srgbClr val="D9D9D9"/>
+                        <a:srgbClr val="D5D9E0"/>
                       </a:solidFill>
                       <a:prstDash val="solid"/>
                       <a:round/>
@@ -3701,7 +3687,7 @@
                     </a:lnL>
                     <a:lnR w="9525" cap="flat" cmpd="sng" algn="ctr">
                       <a:solidFill>
-                        <a:srgbClr val="D9D9D9"/>
+                        <a:srgbClr val="D5D9E0"/>
                       </a:solidFill>
                       <a:prstDash val="solid"/>
                       <a:round/>
@@ -3710,7 +3696,7 @@
                     </a:lnR>
                     <a:lnT w="9525" cap="flat" cmpd="sng" algn="ctr">
                       <a:solidFill>
-                        <a:srgbClr val="D9D9D9"/>
+                        <a:srgbClr val="D5D9E0"/>
                       </a:solidFill>
                       <a:prstDash val="solid"/>
                       <a:round/>
@@ -3719,7 +3705,7 @@
                     </a:lnT>
                     <a:lnB w="9525" cap="flat" cmpd="sng" algn="ctr">
                       <a:solidFill>
-                        <a:srgbClr val="D9D9D9"/>
+                        <a:srgbClr val="D5D9E0"/>
                       </a:solidFill>
                       <a:prstDash val="solid"/>
                       <a:round/>
@@ -3732,7 +3718,7 @@
                   </a:tcPr>
                 </a:tc>
               </a:tr>
-              <a:tr h="457200">
+              <a:tr h="0">
                 <a:tc>
                   <a:txBody>
                     <a:bodyPr/>
@@ -3742,17 +3728,17 @@
                         <a:buNone/>
                       </a:pPr>
                       <a:r>
-                        <a:rPr lang="en-US" sz="1050" b="1" dirty="0">
+                        <a:rPr lang="en-US" sz="1100" b="1" dirty="0">
                           <a:solidFill>
-                            <a:srgbClr val="202020"/>
+                            <a:srgbClr val="5B6072"/>
                           </a:solidFill>
                           <a:latin typeface="Calibri" pitchFamily="34" charset="0"/>
-                          <a:ea typeface="Calibri" pitchFamily="34" charset="-122"/>
-                          <a:cs typeface="Calibri" pitchFamily="34" charset="-120"/>
+                          <a:ea typeface="Calibri" pitchFamily="34"/>
+                          <a:cs typeface="Calibri" pitchFamily="34"/>
                         </a:rPr>
                         <a:t>Generate transaction ID</a:t>
                       </a:r>
-                      <a:endParaRPr lang="en-US" sz="1050" dirty="0">
+                      <a:endParaRPr lang="en-US" sz="1100" dirty="0">
                         <a:latin typeface="Calibri" charset="0"/>
                         <a:ea typeface="Calibri" charset="0"/>
                         <a:cs typeface="Calibri" charset="0"/>
@@ -3762,7 +3748,7 @@
                   <a:tcPr marL="91440" marR="91440" marT="45720" marB="45720" anchor="ctr">
                     <a:lnL w="9525" cap="flat" cmpd="sng" algn="ctr">
                       <a:solidFill>
-                        <a:srgbClr val="D9D9D9"/>
+                        <a:srgbClr val="D5D9E0"/>
                       </a:solidFill>
                       <a:prstDash val="solid"/>
                       <a:round/>
@@ -3771,7 +3757,7 @@
                     </a:lnL>
                     <a:lnR w="9525" cap="flat" cmpd="sng" algn="ctr">
                       <a:solidFill>
-                        <a:srgbClr val="D9D9D9"/>
+                        <a:srgbClr val="D5D9E0"/>
                       </a:solidFill>
                       <a:prstDash val="solid"/>
                       <a:round/>
@@ -3780,7 +3766,7 @@
                     </a:lnR>
                     <a:lnT w="9525" cap="flat" cmpd="sng" algn="ctr">
                       <a:solidFill>
-                        <a:srgbClr val="D9D9D9"/>
+                        <a:srgbClr val="D5D9E0"/>
                       </a:solidFill>
                       <a:prstDash val="solid"/>
                       <a:round/>
@@ -3789,7 +3775,7 @@
                     </a:lnT>
                     <a:lnB w="9525" cap="flat" cmpd="sng" algn="ctr">
                       <a:solidFill>
-                        <a:srgbClr val="D9D9D9"/>
+                        <a:srgbClr val="D5D9E0"/>
                       </a:solidFill>
                       <a:prstDash val="solid"/>
                       <a:round/>
@@ -3797,7 +3783,7 @@
                       <a:tailEnd type="none" w="med" len="med"/>
                     </a:lnB>
                     <a:solidFill>
-                      <a:srgbClr val="F4F6FC"/>
+                      <a:srgbClr val="F7F8FA"/>
                     </a:solidFill>
                   </a:tcPr>
                 </a:tc>
@@ -3810,17 +3796,17 @@
                         <a:buNone/>
                       </a:pPr>
                       <a:r>
-                        <a:rPr lang="en-US" sz="1050" dirty="0">
+                        <a:rPr lang="en-US" sz="1100" dirty="0">
                           <a:solidFill>
-                            <a:srgbClr val="202020"/>
+                            <a:srgbClr val="5B6072"/>
                           </a:solidFill>
                           <a:latin typeface="Calibri" pitchFamily="34" charset="0"/>
-                          <a:ea typeface="Calibri" pitchFamily="34" charset="-122"/>
-                          <a:cs typeface="Calibri" pitchFamily="34" charset="-120"/>
+                          <a:ea typeface="Calibri" pitchFamily="34"/>
+                          <a:cs typeface="Calibri" pitchFamily="34"/>
                         </a:rPr>
                         <a:t>—</a:t>
                       </a:r>
-                      <a:endParaRPr lang="en-US" sz="1050" dirty="0">
+                      <a:endParaRPr lang="en-US" sz="1100" dirty="0">
                         <a:latin typeface="Calibri" charset="0"/>
                         <a:ea typeface="Calibri" charset="0"/>
                         <a:cs typeface="Calibri" charset="0"/>
@@ -3830,7 +3816,7 @@
                   <a:tcPr marL="91440" marR="91440" marT="45720" marB="45720" anchor="ctr">
                     <a:lnL w="9525" cap="flat" cmpd="sng" algn="ctr">
                       <a:solidFill>
-                        <a:srgbClr val="D9D9D9"/>
+                        <a:srgbClr val="D5D9E0"/>
                       </a:solidFill>
                       <a:prstDash val="solid"/>
                       <a:round/>
@@ -3839,7 +3825,7 @@
                     </a:lnL>
                     <a:lnR w="9525" cap="flat" cmpd="sng" algn="ctr">
                       <a:solidFill>
-                        <a:srgbClr val="D9D9D9"/>
+                        <a:srgbClr val="D5D9E0"/>
                       </a:solidFill>
                       <a:prstDash val="solid"/>
                       <a:round/>
@@ -3848,7 +3834,7 @@
                     </a:lnR>
                     <a:lnT w="9525" cap="flat" cmpd="sng" algn="ctr">
                       <a:solidFill>
-                        <a:srgbClr val="D9D9D9"/>
+                        <a:srgbClr val="D5D9E0"/>
                       </a:solidFill>
                       <a:prstDash val="solid"/>
                       <a:round/>
@@ -3857,7 +3843,7 @@
                     </a:lnT>
                     <a:lnB w="9525" cap="flat" cmpd="sng" algn="ctr">
                       <a:solidFill>
-                        <a:srgbClr val="D9D9D9"/>
+                        <a:srgbClr val="D5D9E0"/>
                       </a:solidFill>
                       <a:prstDash val="solid"/>
                       <a:round/>
@@ -3865,7 +3851,7 @@
                       <a:tailEnd type="none" w="med" len="med"/>
                     </a:lnB>
                     <a:solidFill>
-                      <a:srgbClr val="F4F6FC"/>
+                      <a:srgbClr val="F7F8FA"/>
                     </a:solidFill>
                   </a:tcPr>
                 </a:tc>
@@ -3878,17 +3864,17 @@
                         <a:buNone/>
                       </a:pPr>
                       <a:r>
-                        <a:rPr lang="en-US" sz="1050" dirty="0">
+                        <a:rPr lang="en-US" sz="1100" dirty="0">
                           <a:solidFill>
-                            <a:srgbClr val="202020"/>
+                            <a:srgbClr val="1E2761"/>
                           </a:solidFill>
                           <a:latin typeface="Calibri" pitchFamily="34" charset="0"/>
-                          <a:ea typeface="Calibri" pitchFamily="34" charset="-122"/>
-                          <a:cs typeface="Calibri" pitchFamily="34" charset="-120"/>
+                          <a:ea typeface="Calibri" pitchFamily="34"/>
+                          <a:cs typeface="Calibri" pitchFamily="34"/>
                         </a:rPr>
                         <a:t>✓ Requests/assigns ID</a:t>
                       </a:r>
-                      <a:endParaRPr lang="en-US" sz="1050" dirty="0">
+                      <a:endParaRPr lang="en-US" sz="1100" dirty="0">
                         <a:latin typeface="Calibri" charset="0"/>
                         <a:ea typeface="Calibri" charset="0"/>
                         <a:cs typeface="Calibri" charset="0"/>
@@ -3898,7 +3884,7 @@
                   <a:tcPr marL="91440" marR="91440" marT="45720" marB="45720" anchor="ctr">
                     <a:lnL w="9525" cap="flat" cmpd="sng" algn="ctr">
                       <a:solidFill>
-                        <a:srgbClr val="D9D9D9"/>
+                        <a:srgbClr val="D5D9E0"/>
                       </a:solidFill>
                       <a:prstDash val="solid"/>
                       <a:round/>
@@ -3907,7 +3893,7 @@
                     </a:lnL>
                     <a:lnR w="9525" cap="flat" cmpd="sng" algn="ctr">
                       <a:solidFill>
-                        <a:srgbClr val="D9D9D9"/>
+                        <a:srgbClr val="D5D9E0"/>
                       </a:solidFill>
                       <a:prstDash val="solid"/>
                       <a:round/>
@@ -3916,7 +3902,7 @@
                     </a:lnR>
                     <a:lnT w="9525" cap="flat" cmpd="sng" algn="ctr">
                       <a:solidFill>
-                        <a:srgbClr val="D9D9D9"/>
+                        <a:srgbClr val="D5D9E0"/>
                       </a:solidFill>
                       <a:prstDash val="solid"/>
                       <a:round/>
@@ -3925,7 +3911,7 @@
                     </a:lnT>
                     <a:lnB w="9525" cap="flat" cmpd="sng" algn="ctr">
                       <a:solidFill>
-                        <a:srgbClr val="D9D9D9"/>
+                        <a:srgbClr val="D5D9E0"/>
                       </a:solidFill>
                       <a:prstDash val="solid"/>
                       <a:round/>
@@ -3933,7 +3919,7 @@
                       <a:tailEnd type="none" w="med" len="med"/>
                     </a:lnB>
                     <a:solidFill>
-                      <a:srgbClr val="F4F6FC"/>
+                      <a:srgbClr val="F7F8FA"/>
                     </a:solidFill>
                   </a:tcPr>
                 </a:tc>
@@ -3946,17 +3932,17 @@
                         <a:buNone/>
                       </a:pPr>
                       <a:r>
-                        <a:rPr lang="en-US" sz="1050" dirty="0">
+                        <a:rPr lang="en-US" sz="1100" dirty="0">
                           <a:solidFill>
-                            <a:srgbClr val="202020"/>
+                            <a:srgbClr val="1E2761"/>
                           </a:solidFill>
                           <a:latin typeface="Calibri" pitchFamily="34" charset="0"/>
-                          <a:ea typeface="Calibri" pitchFamily="34" charset="-122"/>
-                          <a:cs typeface="Calibri" pitchFamily="34" charset="-120"/>
+                          <a:ea typeface="Calibri" pitchFamily="34"/>
+                          <a:cs typeface="Calibri" pitchFamily="34"/>
                         </a:rPr>
                         <a:t>✓ Guarantees uniqueness</a:t>
                       </a:r>
-                      <a:endParaRPr lang="en-US" sz="1050" dirty="0">
+                      <a:endParaRPr lang="en-US" sz="1100" dirty="0">
                         <a:latin typeface="Calibri" charset="0"/>
                         <a:ea typeface="Calibri" charset="0"/>
                         <a:cs typeface="Calibri" charset="0"/>
@@ -3966,7 +3952,7 @@
                   <a:tcPr marL="91440" marR="91440" marT="45720" marB="45720" anchor="ctr">
                     <a:lnL w="9525" cap="flat" cmpd="sng" algn="ctr">
                       <a:solidFill>
-                        <a:srgbClr val="D9D9D9"/>
+                        <a:srgbClr val="D5D9E0"/>
                       </a:solidFill>
                       <a:prstDash val="solid"/>
                       <a:round/>
@@ -3975,7 +3961,7 @@
                     </a:lnL>
                     <a:lnR w="9525" cap="flat" cmpd="sng" algn="ctr">
                       <a:solidFill>
-                        <a:srgbClr val="D9D9D9"/>
+                        <a:srgbClr val="D5D9E0"/>
                       </a:solidFill>
                       <a:prstDash val="solid"/>
                       <a:round/>
@@ -3984,7 +3970,7 @@
                     </a:lnR>
                     <a:lnT w="9525" cap="flat" cmpd="sng" algn="ctr">
                       <a:solidFill>
-                        <a:srgbClr val="D9D9D9"/>
+                        <a:srgbClr val="D5D9E0"/>
                       </a:solidFill>
                       <a:prstDash val="solid"/>
                       <a:round/>
@@ -3993,7 +3979,7 @@
                     </a:lnT>
                     <a:lnB w="9525" cap="flat" cmpd="sng" algn="ctr">
                       <a:solidFill>
-                        <a:srgbClr val="D9D9D9"/>
+                        <a:srgbClr val="D5D9E0"/>
                       </a:solidFill>
                       <a:prstDash val="solid"/>
                       <a:round/>
@@ -4001,12 +3987,12 @@
                       <a:tailEnd type="none" w="med" len="med"/>
                     </a:lnB>
                     <a:solidFill>
-                      <a:srgbClr val="F4F6FC"/>
+                      <a:srgbClr val="F7F8FA"/>
                     </a:solidFill>
                   </a:tcPr>
                 </a:tc>
               </a:tr>
-              <a:tr h="457200">
+              <a:tr h="0">
                 <a:tc>
                   <a:txBody>
                     <a:bodyPr/>
@@ -4016,17 +4002,17 @@
                         <a:buNone/>
                       </a:pPr>
                       <a:r>
-                        <a:rPr lang="en-US" sz="1050" b="1" dirty="0">
+                        <a:rPr lang="en-US" sz="1100" b="1" dirty="0">
                           <a:solidFill>
-                            <a:srgbClr val="202020"/>
+                            <a:srgbClr val="5B6072"/>
                           </a:solidFill>
                           <a:latin typeface="Calibri" pitchFamily="34" charset="0"/>
-                          <a:ea typeface="Calibri" pitchFamily="34" charset="-122"/>
-                          <a:cs typeface="Calibri" pitchFamily="34" charset="-120"/>
+                          <a:ea typeface="Calibri" pitchFamily="34"/>
+                          <a:cs typeface="Calibri" pitchFamily="34"/>
                         </a:rPr>
                         <a:t>Persist official record</a:t>
                       </a:r>
-                      <a:endParaRPr lang="en-US" sz="1050" dirty="0">
+                      <a:endParaRPr lang="en-US" sz="1100" dirty="0">
                         <a:latin typeface="Calibri" charset="0"/>
                         <a:ea typeface="Calibri" charset="0"/>
                         <a:cs typeface="Calibri" charset="0"/>
@@ -4036,7 +4022,7 @@
                   <a:tcPr marL="91440" marR="91440" marT="45720" marB="45720" anchor="ctr">
                     <a:lnL w="9525" cap="flat" cmpd="sng" algn="ctr">
                       <a:solidFill>
-                        <a:srgbClr val="D9D9D9"/>
+                        <a:srgbClr val="D5D9E0"/>
                       </a:solidFill>
                       <a:prstDash val="solid"/>
                       <a:round/>
@@ -4045,7 +4031,7 @@
                     </a:lnL>
                     <a:lnR w="9525" cap="flat" cmpd="sng" algn="ctr">
                       <a:solidFill>
-                        <a:srgbClr val="D9D9D9"/>
+                        <a:srgbClr val="D5D9E0"/>
                       </a:solidFill>
                       <a:prstDash val="solid"/>
                       <a:round/>
@@ -4054,7 +4040,7 @@
                     </a:lnR>
                     <a:lnT w="9525" cap="flat" cmpd="sng" algn="ctr">
                       <a:solidFill>
-                        <a:srgbClr val="D9D9D9"/>
+                        <a:srgbClr val="D5D9E0"/>
                       </a:solidFill>
                       <a:prstDash val="solid"/>
                       <a:round/>
@@ -4063,7 +4049,7 @@
                     </a:lnT>
                     <a:lnB w="9525" cap="flat" cmpd="sng" algn="ctr">
                       <a:solidFill>
-                        <a:srgbClr val="D9D9D9"/>
+                        <a:srgbClr val="D5D9E0"/>
                       </a:solidFill>
                       <a:prstDash val="solid"/>
                       <a:round/>
@@ -4084,17 +4070,17 @@
                         <a:buNone/>
                       </a:pPr>
                       <a:r>
-                        <a:rPr lang="en-US" sz="1050" dirty="0">
+                        <a:rPr lang="en-US" sz="1100" dirty="0">
                           <a:solidFill>
-                            <a:srgbClr val="202020"/>
+                            <a:srgbClr val="5B6072"/>
                           </a:solidFill>
                           <a:latin typeface="Calibri" pitchFamily="34" charset="0"/>
-                          <a:ea typeface="Calibri" pitchFamily="34" charset="-122"/>
-                          <a:cs typeface="Calibri" pitchFamily="34" charset="-120"/>
+                          <a:ea typeface="Calibri" pitchFamily="34"/>
+                          <a:cs typeface="Calibri" pitchFamily="34"/>
                         </a:rPr>
                         <a:t>—</a:t>
                       </a:r>
-                      <a:endParaRPr lang="en-US" sz="1050" dirty="0">
+                      <a:endParaRPr lang="en-US" sz="1100" dirty="0">
                         <a:latin typeface="Calibri" charset="0"/>
                         <a:ea typeface="Calibri" charset="0"/>
                         <a:cs typeface="Calibri" charset="0"/>
@@ -4104,7 +4090,7 @@
                   <a:tcPr marL="91440" marR="91440" marT="45720" marB="45720" anchor="ctr">
                     <a:lnL w="9525" cap="flat" cmpd="sng" algn="ctr">
                       <a:solidFill>
-                        <a:srgbClr val="D9D9D9"/>
+                        <a:srgbClr val="D5D9E0"/>
                       </a:solidFill>
                       <a:prstDash val="solid"/>
                       <a:round/>
@@ -4113,7 +4099,7 @@
                     </a:lnL>
                     <a:lnR w="9525" cap="flat" cmpd="sng" algn="ctr">
                       <a:solidFill>
-                        <a:srgbClr val="D9D9D9"/>
+                        <a:srgbClr val="D5D9E0"/>
                       </a:solidFill>
                       <a:prstDash val="solid"/>
                       <a:round/>
@@ -4122,7 +4108,7 @@
                     </a:lnR>
                     <a:lnT w="9525" cap="flat" cmpd="sng" algn="ctr">
                       <a:solidFill>
-                        <a:srgbClr val="D9D9D9"/>
+                        <a:srgbClr val="D5D9E0"/>
                       </a:solidFill>
                       <a:prstDash val="solid"/>
                       <a:round/>
@@ -4131,7 +4117,7 @@
                     </a:lnT>
                     <a:lnB w="9525" cap="flat" cmpd="sng" algn="ctr">
                       <a:solidFill>
-                        <a:srgbClr val="D9D9D9"/>
+                        <a:srgbClr val="D5D9E0"/>
                       </a:solidFill>
                       <a:prstDash val="solid"/>
                       <a:round/>
@@ -4152,17 +4138,17 @@
                         <a:buNone/>
                       </a:pPr>
                       <a:r>
-                        <a:rPr lang="en-US" sz="1050" dirty="0">
+                        <a:rPr lang="en-US" sz="1100" dirty="0">
                           <a:solidFill>
-                            <a:srgbClr val="202020"/>
+                            <a:srgbClr val="5B6072"/>
                           </a:solidFill>
                           <a:latin typeface="Calibri" pitchFamily="34" charset="0"/>
-                          <a:ea typeface="Calibri" pitchFamily="34" charset="-122"/>
-                          <a:cs typeface="Calibri" pitchFamily="34" charset="-120"/>
+                          <a:ea typeface="Calibri" pitchFamily="34"/>
+                          <a:cs typeface="Calibri" pitchFamily="34"/>
                         </a:rPr>
                         <a:t>—</a:t>
                       </a:r>
-                      <a:endParaRPr lang="en-US" sz="1050" dirty="0">
+                      <a:endParaRPr lang="en-US" sz="1100" dirty="0">
                         <a:latin typeface="Calibri" charset="0"/>
                         <a:ea typeface="Calibri" charset="0"/>
                         <a:cs typeface="Calibri" charset="0"/>
@@ -4172,7 +4158,7 @@
                   <a:tcPr marL="91440" marR="91440" marT="45720" marB="45720" anchor="ctr">
                     <a:lnL w="9525" cap="flat" cmpd="sng" algn="ctr">
                       <a:solidFill>
-                        <a:srgbClr val="D9D9D9"/>
+                        <a:srgbClr val="D5D9E0"/>
                       </a:solidFill>
                       <a:prstDash val="solid"/>
                       <a:round/>
@@ -4181,7 +4167,7 @@
                     </a:lnL>
                     <a:lnR w="9525" cap="flat" cmpd="sng" algn="ctr">
                       <a:solidFill>
-                        <a:srgbClr val="D9D9D9"/>
+                        <a:srgbClr val="D5D9E0"/>
                       </a:solidFill>
                       <a:prstDash val="solid"/>
                       <a:round/>
@@ -4190,7 +4176,7 @@
                     </a:lnR>
                     <a:lnT w="9525" cap="flat" cmpd="sng" algn="ctr">
                       <a:solidFill>
-                        <a:srgbClr val="D9D9D9"/>
+                        <a:srgbClr val="D5D9E0"/>
                       </a:solidFill>
                       <a:prstDash val="solid"/>
                       <a:round/>
@@ -4199,7 +4185,7 @@
                     </a:lnT>
                     <a:lnB w="9525" cap="flat" cmpd="sng" algn="ctr">
                       <a:solidFill>
-                        <a:srgbClr val="D9D9D9"/>
+                        <a:srgbClr val="D5D9E0"/>
                       </a:solidFill>
                       <a:prstDash val="solid"/>
                       <a:round/>
@@ -4220,17 +4206,17 @@
                         <a:buNone/>
                       </a:pPr>
                       <a:r>
-                        <a:rPr lang="en-US" sz="1050" dirty="0">
+                        <a:rPr lang="en-US" sz="1100" dirty="0">
                           <a:solidFill>
-                            <a:srgbClr val="202020"/>
+                            <a:srgbClr val="1E2761"/>
                           </a:solidFill>
                           <a:latin typeface="Calibri" pitchFamily="34" charset="0"/>
-                          <a:ea typeface="Calibri" pitchFamily="34" charset="-122"/>
-                          <a:cs typeface="Calibri" pitchFamily="34" charset="-120"/>
+                          <a:ea typeface="Calibri" pitchFamily="34"/>
+                          <a:cs typeface="Calibri" pitchFamily="34"/>
                         </a:rPr>
                         <a:t>✓ System of record</a:t>
                       </a:r>
-                      <a:endParaRPr lang="en-US" sz="1050" dirty="0">
+                      <a:endParaRPr lang="en-US" sz="1100" dirty="0">
                         <a:latin typeface="Calibri" charset="0"/>
                         <a:ea typeface="Calibri" charset="0"/>
                         <a:cs typeface="Calibri" charset="0"/>
@@ -4240,7 +4226,7 @@
                   <a:tcPr marL="91440" marR="91440" marT="45720" marB="45720" anchor="ctr">
                     <a:lnL w="9525" cap="flat" cmpd="sng" algn="ctr">
                       <a:solidFill>
-                        <a:srgbClr val="D9D9D9"/>
+                        <a:srgbClr val="D5D9E0"/>
                       </a:solidFill>
                       <a:prstDash val="solid"/>
                       <a:round/>
@@ -4249,7 +4235,7 @@
                     </a:lnL>
                     <a:lnR w="9525" cap="flat" cmpd="sng" algn="ctr">
                       <a:solidFill>
-                        <a:srgbClr val="D9D9D9"/>
+                        <a:srgbClr val="D5D9E0"/>
                       </a:solidFill>
                       <a:prstDash val="solid"/>
                       <a:round/>
@@ -4258,7 +4244,7 @@
                     </a:lnR>
                     <a:lnT w="9525" cap="flat" cmpd="sng" algn="ctr">
                       <a:solidFill>
-                        <a:srgbClr val="D9D9D9"/>
+                        <a:srgbClr val="D5D9E0"/>
                       </a:solidFill>
                       <a:prstDash val="solid"/>
                       <a:round/>
@@ -4267,7 +4253,7 @@
                     </a:lnT>
                     <a:lnB w="9525" cap="flat" cmpd="sng" algn="ctr">
                       <a:solidFill>
-                        <a:srgbClr val="D9D9D9"/>
+                        <a:srgbClr val="D5D9E0"/>
                       </a:solidFill>
                       <a:prstDash val="solid"/>
                       <a:round/>
@@ -4280,7 +4266,7 @@
                   </a:tcPr>
                 </a:tc>
               </a:tr>
-              <a:tr h="457200">
+              <a:tr h="0">
                 <a:tc>
                   <a:txBody>
                     <a:bodyPr/>
@@ -4290,17 +4276,17 @@
                         <a:buNone/>
                       </a:pPr>
                       <a:r>
-                        <a:rPr lang="en-US" sz="1050" b="1" dirty="0">
+                        <a:rPr lang="en-US" sz="1100" b="1" dirty="0">
                           <a:solidFill>
-                            <a:srgbClr val="202020"/>
+                            <a:srgbClr val="5B6072"/>
                           </a:solidFill>
                           <a:latin typeface="Calibri" pitchFamily="34" charset="0"/>
-                          <a:ea typeface="Calibri" pitchFamily="34" charset="-122"/>
-                          <a:cs typeface="Calibri" pitchFamily="34" charset="-120"/>
+                          <a:ea typeface="Calibri" pitchFamily="34"/>
+                          <a:cs typeface="Calibri" pitchFamily="34"/>
                         </a:rPr>
                         <a:t>Audit / history</a:t>
                       </a:r>
-                      <a:endParaRPr lang="en-US" sz="1050" dirty="0">
+                      <a:endParaRPr lang="en-US" sz="1100" dirty="0">
                         <a:latin typeface="Calibri" charset="0"/>
                         <a:ea typeface="Calibri" charset="0"/>
                         <a:cs typeface="Calibri" charset="0"/>
@@ -4310,7 +4296,7 @@
                   <a:tcPr marL="91440" marR="91440" marT="45720" marB="45720" anchor="ctr">
                     <a:lnL w="9525" cap="flat" cmpd="sng" algn="ctr">
                       <a:solidFill>
-                        <a:srgbClr val="D9D9D9"/>
+                        <a:srgbClr val="D5D9E0"/>
                       </a:solidFill>
                       <a:prstDash val="solid"/>
                       <a:round/>
@@ -4319,7 +4305,7 @@
                     </a:lnL>
                     <a:lnR w="9525" cap="flat" cmpd="sng" algn="ctr">
                       <a:solidFill>
-                        <a:srgbClr val="D9D9D9"/>
+                        <a:srgbClr val="D5D9E0"/>
                       </a:solidFill>
                       <a:prstDash val="solid"/>
                       <a:round/>
@@ -4328,7 +4314,7 @@
                     </a:lnR>
                     <a:lnT w="9525" cap="flat" cmpd="sng" algn="ctr">
                       <a:solidFill>
-                        <a:srgbClr val="D9D9D9"/>
+                        <a:srgbClr val="D5D9E0"/>
                       </a:solidFill>
                       <a:prstDash val="solid"/>
                       <a:round/>
@@ -4337,7 +4323,7 @@
                     </a:lnT>
                     <a:lnB w="9525" cap="flat" cmpd="sng" algn="ctr">
                       <a:solidFill>
-                        <a:srgbClr val="D9D9D9"/>
+                        <a:srgbClr val="D5D9E0"/>
                       </a:solidFill>
                       <a:prstDash val="solid"/>
                       <a:round/>
@@ -4345,7 +4331,7 @@
                       <a:tailEnd type="none" w="med" len="med"/>
                     </a:lnB>
                     <a:solidFill>
-                      <a:srgbClr val="F4F6FC"/>
+                      <a:srgbClr val="F7F8FA"/>
                     </a:solidFill>
                   </a:tcPr>
                 </a:tc>
@@ -4358,17 +4344,17 @@
                         <a:buNone/>
                       </a:pPr>
                       <a:r>
-                        <a:rPr lang="en-US" sz="1050" dirty="0">
+                        <a:rPr lang="en-US" sz="1100" dirty="0">
                           <a:solidFill>
-                            <a:srgbClr val="202020"/>
+                            <a:srgbClr val="5B6072"/>
                           </a:solidFill>
                           <a:latin typeface="Calibri" pitchFamily="34" charset="0"/>
-                          <a:ea typeface="Calibri" pitchFamily="34" charset="-122"/>
-                          <a:cs typeface="Calibri" pitchFamily="34" charset="-120"/>
+                          <a:ea typeface="Calibri" pitchFamily="34"/>
+                          <a:cs typeface="Calibri" pitchFamily="34"/>
                         </a:rPr>
                         <a:t>—</a:t>
                       </a:r>
-                      <a:endParaRPr lang="en-US" sz="1050" dirty="0">
+                      <a:endParaRPr lang="en-US" sz="1100" dirty="0">
                         <a:latin typeface="Calibri" charset="0"/>
                         <a:ea typeface="Calibri" charset="0"/>
                         <a:cs typeface="Calibri" charset="0"/>
@@ -4378,7 +4364,7 @@
                   <a:tcPr marL="91440" marR="91440" marT="45720" marB="45720" anchor="ctr">
                     <a:lnL w="9525" cap="flat" cmpd="sng" algn="ctr">
                       <a:solidFill>
-                        <a:srgbClr val="D9D9D9"/>
+                        <a:srgbClr val="D5D9E0"/>
                       </a:solidFill>
                       <a:prstDash val="solid"/>
                       <a:round/>
@@ -4387,7 +4373,7 @@
                     </a:lnL>
                     <a:lnR w="9525" cap="flat" cmpd="sng" algn="ctr">
                       <a:solidFill>
-                        <a:srgbClr val="D9D9D9"/>
+                        <a:srgbClr val="D5D9E0"/>
                       </a:solidFill>
                       <a:prstDash val="solid"/>
                       <a:round/>
@@ -4396,7 +4382,7 @@
                     </a:lnR>
                     <a:lnT w="9525" cap="flat" cmpd="sng" algn="ctr">
                       <a:solidFill>
-                        <a:srgbClr val="D9D9D9"/>
+                        <a:srgbClr val="D5D9E0"/>
                       </a:solidFill>
                       <a:prstDash val="solid"/>
                       <a:round/>
@@ -4405,7 +4391,7 @@
                     </a:lnT>
                     <a:lnB w="9525" cap="flat" cmpd="sng" algn="ctr">
                       <a:solidFill>
-                        <a:srgbClr val="D9D9D9"/>
+                        <a:srgbClr val="D5D9E0"/>
                       </a:solidFill>
                       <a:prstDash val="solid"/>
                       <a:round/>
@@ -4413,7 +4399,7 @@
                       <a:tailEnd type="none" w="med" len="med"/>
                     </a:lnB>
                     <a:solidFill>
-                      <a:srgbClr val="F4F6FC"/>
+                      <a:srgbClr val="F7F8FA"/>
                     </a:solidFill>
                   </a:tcPr>
                 </a:tc>
@@ -4426,17 +4412,17 @@
                         <a:buNone/>
                       </a:pPr>
                       <a:r>
-                        <a:rPr lang="en-US" sz="1050" dirty="0">
+                        <a:rPr lang="en-US" sz="1100" dirty="0">
                           <a:solidFill>
-                            <a:srgbClr val="202020"/>
+                            <a:srgbClr val="1E2761"/>
                           </a:solidFill>
                           <a:latin typeface="Calibri" pitchFamily="34" charset="0"/>
-                          <a:ea typeface="Calibri" pitchFamily="34" charset="-122"/>
-                          <a:cs typeface="Calibri" pitchFamily="34" charset="-120"/>
+                          <a:ea typeface="Calibri" pitchFamily="34"/>
+                          <a:cs typeface="Calibri" pitchFamily="34"/>
                         </a:rPr>
                         <a:t>✓ Triggers log entry</a:t>
                       </a:r>
-                      <a:endParaRPr lang="en-US" sz="1050" dirty="0">
+                      <a:endParaRPr lang="en-US" sz="1100" dirty="0">
                         <a:latin typeface="Calibri" charset="0"/>
                         <a:ea typeface="Calibri" charset="0"/>
                         <a:cs typeface="Calibri" charset="0"/>
@@ -4446,7 +4432,7 @@
                   <a:tcPr marL="91440" marR="91440" marT="45720" marB="45720" anchor="ctr">
                     <a:lnL w="9525" cap="flat" cmpd="sng" algn="ctr">
                       <a:solidFill>
-                        <a:srgbClr val="D9D9D9"/>
+                        <a:srgbClr val="D5D9E0"/>
                       </a:solidFill>
                       <a:prstDash val="solid"/>
                       <a:round/>
@@ -4455,7 +4441,7 @@
                     </a:lnL>
                     <a:lnR w="9525" cap="flat" cmpd="sng" algn="ctr">
                       <a:solidFill>
-                        <a:srgbClr val="D9D9D9"/>
+                        <a:srgbClr val="D5D9E0"/>
                       </a:solidFill>
                       <a:prstDash val="solid"/>
                       <a:round/>
@@ -4464,7 +4450,7 @@
                     </a:lnR>
                     <a:lnT w="9525" cap="flat" cmpd="sng" algn="ctr">
                       <a:solidFill>
-                        <a:srgbClr val="D9D9D9"/>
+                        <a:srgbClr val="D5D9E0"/>
                       </a:solidFill>
                       <a:prstDash val="solid"/>
                       <a:round/>
@@ -4473,7 +4459,7 @@
                     </a:lnT>
                     <a:lnB w="9525" cap="flat" cmpd="sng" algn="ctr">
                       <a:solidFill>
-                        <a:srgbClr val="D9D9D9"/>
+                        <a:srgbClr val="D5D9E0"/>
                       </a:solidFill>
                       <a:prstDash val="solid"/>
                       <a:round/>
@@ -4481,7 +4467,7 @@
                       <a:tailEnd type="none" w="med" len="med"/>
                     </a:lnB>
                     <a:solidFill>
-                      <a:srgbClr val="F4F6FC"/>
+                      <a:srgbClr val="F7F8FA"/>
                     </a:solidFill>
                   </a:tcPr>
                 </a:tc>
@@ -4494,17 +4480,17 @@
                         <a:buNone/>
                       </a:pPr>
                       <a:r>
-                        <a:rPr lang="en-US" sz="1050" dirty="0">
+                        <a:rPr lang="en-US" sz="1100" dirty="0">
                           <a:solidFill>
-                            <a:srgbClr val="202020"/>
+                            <a:srgbClr val="1E2761"/>
                           </a:solidFill>
                           <a:latin typeface="Calibri" pitchFamily="34" charset="0"/>
-                          <a:ea typeface="Calibri" pitchFamily="34" charset="-122"/>
-                          <a:cs typeface="Calibri" pitchFamily="34" charset="-120"/>
+                          <a:ea typeface="Calibri" pitchFamily="34"/>
+                          <a:cs typeface="Calibri" pitchFamily="34"/>
                         </a:rPr>
                         <a:t>✓ Stores audit trail</a:t>
                       </a:r>
-                      <a:endParaRPr lang="en-US" sz="1050" dirty="0">
+                      <a:endParaRPr lang="en-US" sz="1100" dirty="0">
                         <a:latin typeface="Calibri" charset="0"/>
                         <a:ea typeface="Calibri" charset="0"/>
                         <a:cs typeface="Calibri" charset="0"/>
@@ -4514,7 +4500,7 @@
                   <a:tcPr marL="91440" marR="91440" marT="45720" marB="45720" anchor="ctr">
                     <a:lnL w="9525" cap="flat" cmpd="sng" algn="ctr">
                       <a:solidFill>
-                        <a:srgbClr val="D9D9D9"/>
+                        <a:srgbClr val="D5D9E0"/>
                       </a:solidFill>
                       <a:prstDash val="solid"/>
                       <a:round/>
@@ -4523,7 +4509,7 @@
                     </a:lnL>
                     <a:lnR w="9525" cap="flat" cmpd="sng" algn="ctr">
                       <a:solidFill>
-                        <a:srgbClr val="D9D9D9"/>
+                        <a:srgbClr val="D5D9E0"/>
                       </a:solidFill>
                       <a:prstDash val="solid"/>
                       <a:round/>
@@ -4532,7 +4518,7 @@
                     </a:lnR>
                     <a:lnT w="9525" cap="flat" cmpd="sng" algn="ctr">
                       <a:solidFill>
-                        <a:srgbClr val="D9D9D9"/>
+                        <a:srgbClr val="D5D9E0"/>
                       </a:solidFill>
                       <a:prstDash val="solid"/>
                       <a:round/>
@@ -4541,7 +4527,7 @@
                     </a:lnT>
                     <a:lnB w="9525" cap="flat" cmpd="sng" algn="ctr">
                       <a:solidFill>
-                        <a:srgbClr val="D9D9D9"/>
+                        <a:srgbClr val="D5D9E0"/>
                       </a:solidFill>
                       <a:prstDash val="solid"/>
                       <a:round/>
@@ -4549,12 +4535,12 @@
                       <a:tailEnd type="none" w="med" len="med"/>
                     </a:lnB>
                     <a:solidFill>
-                      <a:srgbClr val="F4F6FC"/>
+                      <a:srgbClr val="F7F8FA"/>
                     </a:solidFill>
                   </a:tcPr>
                 </a:tc>
               </a:tr>
-              <a:tr h="457200">
+              <a:tr h="0">
                 <a:tc>
                   <a:txBody>
                     <a:bodyPr/>
@@ -4564,17 +4550,17 @@
                         <a:buNone/>
                       </a:pPr>
                       <a:r>
-                        <a:rPr lang="en-US" sz="1050" b="1" dirty="0">
+                        <a:rPr lang="en-US" sz="1100" b="1" dirty="0">
                           <a:solidFill>
-                            <a:srgbClr val="202020"/>
+                            <a:srgbClr val="5B6072"/>
                           </a:solidFill>
                           <a:latin typeface="Calibri" pitchFamily="34" charset="0"/>
-                          <a:ea typeface="Calibri" pitchFamily="34" charset="-122"/>
-                          <a:cs typeface="Calibri" pitchFamily="34" charset="-120"/>
+                          <a:ea typeface="Calibri" pitchFamily="34"/>
+                          <a:cs typeface="Calibri" pitchFamily="34"/>
                         </a:rPr>
                         <a:t>Display response</a:t>
                       </a:r>
-                      <a:endParaRPr lang="en-US" sz="1050" dirty="0">
+                      <a:endParaRPr lang="en-US" sz="1100" dirty="0">
                         <a:latin typeface="Calibri" charset="0"/>
                         <a:ea typeface="Calibri" charset="0"/>
                         <a:cs typeface="Calibri" charset="0"/>
@@ -4584,7 +4570,7 @@
                   <a:tcPr marL="91440" marR="91440" marT="45720" marB="45720" anchor="ctr">
                     <a:lnL w="9525" cap="flat" cmpd="sng" algn="ctr">
                       <a:solidFill>
-                        <a:srgbClr val="D9D9D9"/>
+                        <a:srgbClr val="D5D9E0"/>
                       </a:solidFill>
                       <a:prstDash val="solid"/>
                       <a:round/>
@@ -4593,7 +4579,7 @@
                     </a:lnL>
                     <a:lnR w="9525" cap="flat" cmpd="sng" algn="ctr">
                       <a:solidFill>
-                        <a:srgbClr val="D9D9D9"/>
+                        <a:srgbClr val="D5D9E0"/>
                       </a:solidFill>
                       <a:prstDash val="solid"/>
                       <a:round/>
@@ -4602,7 +4588,7 @@
                     </a:lnR>
                     <a:lnT w="9525" cap="flat" cmpd="sng" algn="ctr">
                       <a:solidFill>
-                        <a:srgbClr val="D9D9D9"/>
+                        <a:srgbClr val="D5D9E0"/>
                       </a:solidFill>
                       <a:prstDash val="solid"/>
                       <a:round/>
@@ -4611,7 +4597,7 @@
                     </a:lnT>
                     <a:lnB w="9525" cap="flat" cmpd="sng" algn="ctr">
                       <a:solidFill>
-                        <a:srgbClr val="D9D9D9"/>
+                        <a:srgbClr val="D5D9E0"/>
                       </a:solidFill>
                       <a:prstDash val="solid"/>
                       <a:round/>
@@ -4632,17 +4618,17 @@
                         <a:buNone/>
                       </a:pPr>
                       <a:r>
-                        <a:rPr lang="en-US" sz="1050" dirty="0">
+                        <a:rPr lang="en-US" sz="1100" dirty="0">
                           <a:solidFill>
-                            <a:srgbClr val="202020"/>
+                            <a:srgbClr val="1E2761"/>
                           </a:solidFill>
                           <a:latin typeface="Calibri" pitchFamily="34" charset="0"/>
-                          <a:ea typeface="Calibri" pitchFamily="34" charset="-122"/>
-                          <a:cs typeface="Calibri" pitchFamily="34" charset="-120"/>
+                          <a:ea typeface="Calibri" pitchFamily="34"/>
+                          <a:cs typeface="Calibri" pitchFamily="34"/>
                         </a:rPr>
                         <a:t>✓ Primary</a:t>
                       </a:r>
-                      <a:endParaRPr lang="en-US" sz="1050" dirty="0">
+                      <a:endParaRPr lang="en-US" sz="1100" dirty="0">
                         <a:latin typeface="Calibri" charset="0"/>
                         <a:ea typeface="Calibri" charset="0"/>
                         <a:cs typeface="Calibri" charset="0"/>
@@ -4652,7 +4638,7 @@
                   <a:tcPr marL="91440" marR="91440" marT="45720" marB="45720" anchor="ctr">
                     <a:lnL w="9525" cap="flat" cmpd="sng" algn="ctr">
                       <a:solidFill>
-                        <a:srgbClr val="D9D9D9"/>
+                        <a:srgbClr val="D5D9E0"/>
                       </a:solidFill>
                       <a:prstDash val="solid"/>
                       <a:round/>
@@ -4661,7 +4647,7 @@
                     </a:lnL>
                     <a:lnR w="9525" cap="flat" cmpd="sng" algn="ctr">
                       <a:solidFill>
-                        <a:srgbClr val="D9D9D9"/>
+                        <a:srgbClr val="D5D9E0"/>
                       </a:solidFill>
                       <a:prstDash val="solid"/>
                       <a:round/>
@@ -4670,7 +4656,7 @@
                     </a:lnR>
                     <a:lnT w="9525" cap="flat" cmpd="sng" algn="ctr">
                       <a:solidFill>
-                        <a:srgbClr val="D9D9D9"/>
+                        <a:srgbClr val="D5D9E0"/>
                       </a:solidFill>
                       <a:prstDash val="solid"/>
                       <a:round/>
@@ -4679,7 +4665,7 @@
                     </a:lnT>
                     <a:lnB w="9525" cap="flat" cmpd="sng" algn="ctr">
                       <a:solidFill>
-                        <a:srgbClr val="D9D9D9"/>
+                        <a:srgbClr val="D5D9E0"/>
                       </a:solidFill>
                       <a:prstDash val="solid"/>
                       <a:round/>
@@ -4700,17 +4686,17 @@
                         <a:buNone/>
                       </a:pPr>
                       <a:r>
-                        <a:rPr lang="en-US" sz="1050" dirty="0">
+                        <a:rPr lang="en-US" sz="1100" dirty="0">
                           <a:solidFill>
-                            <a:srgbClr val="202020"/>
+                            <a:srgbClr val="5B6072"/>
                           </a:solidFill>
                           <a:latin typeface="Calibri" pitchFamily="34" charset="0"/>
-                          <a:ea typeface="Calibri" pitchFamily="34" charset="-122"/>
-                          <a:cs typeface="Calibri" pitchFamily="34" charset="-120"/>
+                          <a:ea typeface="Calibri" pitchFamily="34"/>
+                          <a:cs typeface="Calibri" pitchFamily="34"/>
                         </a:rPr>
                         <a:t>—</a:t>
                       </a:r>
-                      <a:endParaRPr lang="en-US" sz="1050" dirty="0">
+                      <a:endParaRPr lang="en-US" sz="1100" dirty="0">
                         <a:latin typeface="Calibri" charset="0"/>
                         <a:ea typeface="Calibri" charset="0"/>
                         <a:cs typeface="Calibri" charset="0"/>
@@ -4720,7 +4706,7 @@
                   <a:tcPr marL="91440" marR="91440" marT="45720" marB="45720" anchor="ctr">
                     <a:lnL w="9525" cap="flat" cmpd="sng" algn="ctr">
                       <a:solidFill>
-                        <a:srgbClr val="D9D9D9"/>
+                        <a:srgbClr val="D5D9E0"/>
                       </a:solidFill>
                       <a:prstDash val="solid"/>
                       <a:round/>
@@ -4729,7 +4715,7 @@
                     </a:lnL>
                     <a:lnR w="9525" cap="flat" cmpd="sng" algn="ctr">
                       <a:solidFill>
-                        <a:srgbClr val="D9D9D9"/>
+                        <a:srgbClr val="D5D9E0"/>
                       </a:solidFill>
                       <a:prstDash val="solid"/>
                       <a:round/>
@@ -4738,7 +4724,7 @@
                     </a:lnR>
                     <a:lnT w="9525" cap="flat" cmpd="sng" algn="ctr">
                       <a:solidFill>
-                        <a:srgbClr val="D9D9D9"/>
+                        <a:srgbClr val="D5D9E0"/>
                       </a:solidFill>
                       <a:prstDash val="solid"/>
                       <a:round/>
@@ -4747,7 +4733,7 @@
                     </a:lnT>
                     <a:lnB w="9525" cap="flat" cmpd="sng" algn="ctr">
                       <a:solidFill>
-                        <a:srgbClr val="D9D9D9"/>
+                        <a:srgbClr val="D5D9E0"/>
                       </a:solidFill>
                       <a:prstDash val="solid"/>
                       <a:round/>
@@ -4768,17 +4754,17 @@
                         <a:buNone/>
                       </a:pPr>
                       <a:r>
-                        <a:rPr lang="en-US" sz="1050" dirty="0">
+                        <a:rPr lang="en-US" sz="1100" dirty="0">
                           <a:solidFill>
-                            <a:srgbClr val="202020"/>
+                            <a:srgbClr val="5B6072"/>
                           </a:solidFill>
                           <a:latin typeface="Calibri" pitchFamily="34" charset="0"/>
-                          <a:ea typeface="Calibri" pitchFamily="34" charset="-122"/>
-                          <a:cs typeface="Calibri" pitchFamily="34" charset="-120"/>
+                          <a:ea typeface="Calibri" pitchFamily="34"/>
+                          <a:cs typeface="Calibri" pitchFamily="34"/>
                         </a:rPr>
                         <a:t>—</a:t>
                       </a:r>
-                      <a:endParaRPr lang="en-US" sz="1050" dirty="0">
+                      <a:endParaRPr lang="en-US" sz="1100" dirty="0">
                         <a:latin typeface="Calibri" charset="0"/>
                         <a:ea typeface="Calibri" charset="0"/>
                         <a:cs typeface="Calibri" charset="0"/>
@@ -4788,7 +4774,7 @@
                   <a:tcPr marL="91440" marR="91440" marT="45720" marB="45720" anchor="ctr">
                     <a:lnL w="9525" cap="flat" cmpd="sng" algn="ctr">
                       <a:solidFill>
-                        <a:srgbClr val="D9D9D9"/>
+                        <a:srgbClr val="D5D9E0"/>
                       </a:solidFill>
                       <a:prstDash val="solid"/>
                       <a:round/>
@@ -4797,7 +4783,7 @@
                     </a:lnL>
                     <a:lnR w="9525" cap="flat" cmpd="sng" algn="ctr">
                       <a:solidFill>
-                        <a:srgbClr val="D9D9D9"/>
+                        <a:srgbClr val="D5D9E0"/>
                       </a:solidFill>
                       <a:prstDash val="solid"/>
                       <a:round/>
@@ -4806,7 +4792,7 @@
                     </a:lnR>
                     <a:lnT w="9525" cap="flat" cmpd="sng" algn="ctr">
                       <a:solidFill>
-                        <a:srgbClr val="D9D9D9"/>
+                        <a:srgbClr val="D5D9E0"/>
                       </a:solidFill>
                       <a:prstDash val="solid"/>
                       <a:round/>
@@ -4815,7 +4801,7 @@
                     </a:lnT>
                     <a:lnB w="9525" cap="flat" cmpd="sng" algn="ctr">
                       <a:solidFill>
-                        <a:srgbClr val="D9D9D9"/>
+                        <a:srgbClr val="D5D9E0"/>
                       </a:solidFill>
                       <a:prstDash val="solid"/>
                       <a:round/>
@@ -4872,8 +4858,8 @@
         </p:nvSpPr>
         <p:spPr>
           <a:xfrm>
-            <a:off x="548640" y="320040"/>
-            <a:ext cx="11091672" cy="548640"/>
+            <a:off x="457200" y="320040"/>
+            <a:ext cx="11247120" cy="548640"/>
           </a:xfrm>
           <a:prstGeom prst="rect">
             <a:avLst/>
@@ -4889,17 +4875,17 @@
               <a:buNone/>
             </a:pPr>
             <a:r>
-              <a:rPr lang="en-US" sz="2600" b="1" dirty="0">
+              <a:rPr lang="en-US" sz="2800" b="1" dirty="0">
                 <a:solidFill>
                   <a:srgbClr val="1E2761"/>
                 </a:solidFill>
-                <a:latin typeface="Cambria" pitchFamily="34" charset="0"/>
-                <a:ea typeface="Cambria" pitchFamily="34" charset="-122"/>
-                <a:cs typeface="Cambria" pitchFamily="34" charset="-120"/>
+                <a:latin typeface="Arial" pitchFamily="34" charset="0"/>
+                <a:ea typeface="Arial" pitchFamily="34"/>
+                <a:cs typeface="Arial" pitchFamily="34"/>
               </a:rPr>
               <a:t>Responsibility Notes</a:t>
             </a:r>
-            <a:endParaRPr lang="en-US" sz="2600" dirty="0"/>
+            <a:endParaRPr lang="en-US" sz="2800" dirty="0"/>
           </a:p>
         </p:txBody>
       </p:sp>
@@ -4911,20 +4897,20 @@
         </p:nvSpPr>
         <p:spPr>
           <a:xfrm>
-            <a:off x="548640" y="1417320"/>
-            <a:ext cx="11091672" cy="1737360"/>
+            <a:off x="548640" y="1463040"/>
+            <a:ext cx="11064240" cy="1737360"/>
           </a:xfrm>
           <a:prstGeom prst="roundRect">
             <a:avLst>
-              <a:gd name="adj" fmla="val 4211"/>
+              <a:gd name="adj" fmla="val 2895"/>
             </a:avLst>
           </a:prstGeom>
           <a:solidFill>
-            <a:srgbClr val="F4F6FC"/>
+            <a:srgbClr val="F7F8FA"/>
           </a:solidFill>
-          <a:ln w="9525">
+          <a:ln w="12700">
             <a:solidFill>
-              <a:srgbClr val="1E2761"/>
+              <a:srgbClr val="D5D9E0"/>
             </a:solidFill>
             <a:prstDash val="solid"/>
           </a:ln>
@@ -4938,8 +4924,8 @@
         </p:nvSpPr>
         <p:spPr>
           <a:xfrm>
-            <a:off x="822960" y="1554480"/>
-            <a:ext cx="10543032" cy="320040"/>
+            <a:off x="822960" y="1645920"/>
+            <a:ext cx="10515600" cy="320040"/>
           </a:xfrm>
           <a:prstGeom prst="rect">
             <a:avLst/>
@@ -4955,17 +4941,17 @@
               <a:buNone/>
             </a:pPr>
             <a:r>
-              <a:rPr lang="en-US" sz="1500" b="1" dirty="0">
+              <a:rPr lang="en-US" sz="1400" b="1" dirty="0">
                 <a:solidFill>
                   <a:srgbClr val="1E2761"/>
                 </a:solidFill>
                 <a:latin typeface="Calibri" pitchFamily="34" charset="0"/>
-                <a:ea typeface="Calibri" pitchFamily="34" charset="-122"/>
-                <a:cs typeface="Calibri" pitchFamily="34" charset="-120"/>
+                <a:ea typeface="Calibri" pitchFamily="34"/>
+                <a:cs typeface="Calibri" pitchFamily="34"/>
               </a:rPr>
               <a:t>Authoritative Business Rule (Server / Application Tier)</a:t>
             </a:r>
-            <a:endParaRPr lang="en-US" sz="1500" dirty="0"/>
+            <a:endParaRPr lang="en-US" sz="1400" dirty="0"/>
           </a:p>
         </p:txBody>
       </p:sp>
@@ -4977,8 +4963,8 @@
         </p:nvSpPr>
         <p:spPr>
           <a:xfrm>
-            <a:off x="822960" y="1920240"/>
-            <a:ext cx="10543032" cy="1143000"/>
+            <a:off x="822960" y="2011680"/>
+            <a:ext cx="10515600" cy="1097280"/>
           </a:xfrm>
           <a:prstGeom prst="rect">
             <a:avLst/>
@@ -4999,11 +4985,11 @@
             <a:r>
               <a:rPr lang="en-US" sz="1250" dirty="0">
                 <a:solidFill>
-                  <a:srgbClr val="202020"/>
+                  <a:srgbClr val="222533"/>
                 </a:solidFill>
                 <a:latin typeface="Calibri" pitchFamily="34" charset="0"/>
-                <a:ea typeface="Calibri" pitchFamily="34" charset="-122"/>
-                <a:cs typeface="Calibri" pitchFamily="34" charset="-120"/>
+                <a:ea typeface="Calibri" pitchFamily="34"/>
+                <a:cs typeface="Calibri" pitchFamily="34"/>
               </a:rPr>
               <a:t>BR-4 — “A request citing ‘defective’ for an item valued over $200 requires supervisor approval” — must be enforced in the application tier, not just the client. A customer's browser or form could be bypassed or tampered with, so the server must independently recompute the supervisor-review flag from reason_code and item_value rather than trusting a flag sent from the client.</a:t>
             </a:r>
@@ -5019,20 +5005,20 @@
         </p:nvSpPr>
         <p:spPr>
           <a:xfrm>
-            <a:off x="548640" y="3383280"/>
-            <a:ext cx="11091672" cy="1554480"/>
+            <a:off x="548640" y="3474720"/>
+            <a:ext cx="11064240" cy="1737360"/>
           </a:xfrm>
           <a:prstGeom prst="roundRect">
             <a:avLst>
-              <a:gd name="adj" fmla="val 4706"/>
+              <a:gd name="adj" fmla="val 2895"/>
             </a:avLst>
           </a:prstGeom>
           <a:solidFill>
-            <a:srgbClr val="E4F2EB"/>
+            <a:srgbClr val="0E8C86"/>
           </a:solidFill>
-          <a:ln w="9525">
+          <a:ln w="12700">
             <a:solidFill>
-              <a:srgbClr val="1E6B4E"/>
+              <a:srgbClr val="D5D9E0"/>
             </a:solidFill>
             <a:prstDash val="solid"/>
           </a:ln>
@@ -5046,8 +5032,8 @@
         </p:nvSpPr>
         <p:spPr>
           <a:xfrm>
-            <a:off x="822960" y="3520440"/>
-            <a:ext cx="10543032" cy="320040"/>
+            <a:off x="822960" y="3657600"/>
+            <a:ext cx="10515600" cy="320040"/>
           </a:xfrm>
           <a:prstGeom prst="rect">
             <a:avLst/>
@@ -5063,17 +5049,17 @@
               <a:buNone/>
             </a:pPr>
             <a:r>
-              <a:rPr lang="en-US" sz="1500" b="1" dirty="0">
+              <a:rPr lang="en-US" sz="1400" b="1" dirty="0">
                 <a:solidFill>
-                  <a:srgbClr val="1E6B4E"/>
+                  <a:srgbClr val="FFFFFF"/>
                 </a:solidFill>
                 <a:latin typeface="Calibri" pitchFamily="34" charset="0"/>
-                <a:ea typeface="Calibri" pitchFamily="34" charset="-122"/>
-                <a:cs typeface="Calibri" pitchFamily="34" charset="-120"/>
+                <a:ea typeface="Calibri" pitchFamily="34"/>
+                <a:cs typeface="Calibri" pitchFamily="34"/>
               </a:rPr>
-              <a:t>Audit Requirement</a:t>
+              <a:t>Audit Requirement — Critical Metric</a:t>
             </a:r>
-            <a:endParaRPr lang="en-US" sz="1500" dirty="0"/>
+            <a:endParaRPr lang="en-US" sz="1400" dirty="0"/>
           </a:p>
         </p:txBody>
       </p:sp>
@@ -5085,8 +5071,8 @@
         </p:nvSpPr>
         <p:spPr>
           <a:xfrm>
-            <a:off x="822960" y="3886200"/>
-            <a:ext cx="10543032" cy="960120"/>
+            <a:off x="822960" y="4023360"/>
+            <a:ext cx="10515600" cy="1097280"/>
           </a:xfrm>
           <a:prstGeom prst="rect">
             <a:avLst/>
@@ -5107,11 +5093,11 @@
             <a:r>
               <a:rPr lang="en-US" sz="1250" dirty="0">
                 <a:solidFill>
-                  <a:srgbClr val="202020"/>
+                  <a:srgbClr val="FFFFFF"/>
                 </a:solidFill>
                 <a:latin typeface="Calibri" pitchFamily="34" charset="0"/>
-                <a:ea typeface="Calibri" pitchFamily="34" charset="-122"/>
-                <a:cs typeface="Calibri" pitchFamily="34" charset="-120"/>
+                <a:ea typeface="Calibri" pitchFamily="34"/>
+                <a:cs typeface="Calibri" pitchFamily="34"/>
               </a:rPr>
               <a:t>Every status transition (e.g., Submitted → Pending Supervisor Review → Approved) must be recorded with a timestamp and the actor who caused it (system or supervisor), per NFR-3. This lets the Inventory Auditor trace why and when a return moved through the workflow.</a:t>
             </a:r>

</xml_diff>